<commit_message>
Add target customer and tutor slides to the final pitch deck
Nine slides: new Who slide (U of R undergraduates first, graduate students second) and a tutor slide showing a back-and-forth example conversation. Speaker notes trimmed to keep the pitch under five minutes.
</commit_message>
<xml_diff>
--- a/docs/03-pitch/ENSE400_Final_Pitch_Cultivator.pptx
+++ b/docs/03-pitch/ENSE400_Final_Pitch_Cultivator.pptx
@@ -15,6 +15,8 @@
     <p:sldId id="278" r:id="rId29"/>
     <p:sldId id="279" r:id="rId30"/>
     <p:sldId id="280" r:id="rId31"/>
+    <p:sldId id="281" r:id="rId32"/>
+    <p:sldId id="282" r:id="rId33"/>
   </p:sldIdLst>
   <p:sldSz cy="6858000" cx="12191675"/>
   <p:notesSz cx="6858000" cy="9144000"/>
@@ -1169,7 +1171,7 @@
           <a:p/>
           <a:p>
             <a:r>
-              <a:t>Whole pitch: about 4 minutes, so we stay inside the 5-minute limit.</a:t>
+              <a:t>Whole pitch: about 4.5 minutes, so we stay inside the 5-minute limit.</a:t>
             </a:r>
           </a:p>
           <a:p/>
@@ -1250,25 +1252,19 @@
           <a:lstStyle/>
           <a:p>
             <a:r>
-              <a:t>Aubin. Target 50 seconds.</a:t>
+              <a:t>Aubin. Target 40 seconds.</a:t>
             </a:r>
           </a:p>
           <a:p/>
           <a:p>
             <a:r>
-              <a:t>This started with an interview with Linda, a U of R student. She already studies with ChatGPT, but before she gets any help she has to upload her files and explain what she’s looking at. Chop and I study the same way, so we know this problem well.</a:t>
+              <a:t>This started with an interview with Linda, a U of R student. Before ChatGPT can help her, she has to upload her files and explain what she’s looking at, every single time. Chop and I study the same way.</a:t>
             </a:r>
           </a:p>
           <a:p/>
           <a:p>
             <a:r>
               <a:t>Three things get in the way. Setup: the same files get uploaded and the course explained again every session. Trust: the answer doesn’t point back to a page, so you can’t check it. Practice: flashcards and quizzes are made by hand in another app, so most students skip them until exam time.</a:t>
-            </a:r>
-          </a:p>
-          <a:p/>
-          <a:p>
-            <a:r>
-              <a:t>We’re building this for university students who study from course PDFs, starting here at the U of R.</a:t>
             </a:r>
           </a:p>
           <a:p/>
@@ -1354,36 +1350,29 @@
           <a:lstStyle/>
           <a:p>
             <a:r>
-              <a:t>Aubin. Target 45 seconds.</a:t>
+              <a:t>Aubin. Target 30 seconds.</a:t>
             </a:r>
           </a:p>
           <a:p/>
           <a:p>
             <a:r>
-              <a:t>Here’s a study session in our app. You add the course folders already on your laptop. You open a PDF and select a passage or a whole page. You ask a question, and the answer comes back with the file and page number. Click it and you’re on that page, so checking an answer takes one click.</a:t>
+              <a:t>Our first customers are U of R undergraduates, mostly in engineering, science and business. They study from lecture slides and textbook PDFs, they already use ChatGPT, and they cram before midterms on a student budget. Graduate and thesis students are our second group. Our first users are classmates, testing it on their own course files.</a:t>
             </a:r>
           </a:p>
           <a:p/>
           <a:p>
             <a:r>
-              <a:t>From the same passage, the app makes flashcards and a short quiz. In the winter release it also plans your review before each exam.</a:t>
-            </a:r>
-          </a:p>
-          <a:p/>
-          <a:p>
-            <a:r>
-              <a:t>Your files never leave your laptop. Only the passage you select is sent to the AI model. We start on Windows and macOS, and the iPad version comes in winter.</a:t>
-            </a:r>
-          </a:p>
-          <a:p/>
-          <a:p>
-            <a:r>
-              <a:t>Sources:</a:t>
-            </a:r>
-          </a:p>
-          <a:p>
-            <a:r>
-              <a:t>Project Requirements and User Story Map (Workshop 3).</a:t>
+              <a:t>Sources and photo credits:</a:t>
+            </a:r>
+          </a:p>
+          <a:p>
+            <a:r>
+              <a:t>User Analysis (Workshop 2). Only the Linda interview is validated so far; more student interviews are planned.</a:t>
+            </a:r>
+          </a:p>
+          <a:p>
+            <a:r>
+              <a:t>Illustrative photo: Yan Krukau / Pexels. https://www.pexels.com/photo/students-in-a-library-looking-at-a-tablet-screen-8199599/</a:t>
             </a:r>
           </a:p>
         </p:txBody>
@@ -1453,30 +1442,24 @@
           <a:lstStyle/>
           <a:p>
             <a:r>
-              <a:t>Chop. Target 45 seconds.</a:t>
+              <a:t>Aubin. Target 35 seconds.</a:t>
             </a:r>
           </a:p>
           <a:p/>
           <a:p>
             <a:r>
-              <a:t>Students already have good tools, and each one does part of the job. NotebookLM gives cited answers and quizzes, but every file has to be uploaded first. Acrobat answers questions about one PDF at a time and has no practice. ChatGPT and Gemini explain well, but you set up the context again every session. Anki and Quizlet work for review, but you make every card by hand.</a:t>
+              <a:t>Here’s how a session works. You add your course folders, open a PDF and select a passage or a page. You ask about it, and every answer shows the page it came from, so checking it takes one click. From the same passage, the app makes flashcards and a quiz, and in winter it plans your review before each exam. Your files stay on your laptop. Only the passage you select goes to the AI.</a:t>
             </a:r>
           </a:p>
           <a:p/>
           <a:p>
             <a:r>
-              <a:t>Our unique value: it explains the page you’re reading, cites it and turns it into practice, straight from your own files. We’re not trying to beat these tools on answer quality. We win on setup time.</a:t>
-            </a:r>
-          </a:p>
-          <a:p/>
-          <a:p>
-            <a:r>
               <a:t>Sources:</a:t>
             </a:r>
           </a:p>
           <a:p>
             <a:r>
-              <a:t>Competitor Analysis (Workshop 1) and Business Case (Workshop 3).</a:t>
+              <a:t>Project Requirements and User Story Map (Workshop 3).</a:t>
             </a:r>
           </a:p>
         </p:txBody>
@@ -1546,36 +1529,19 @@
           <a:lstStyle/>
           <a:p>
             <a:r>
-              <a:t>Chop. Target 45 seconds.</a:t>
+              <a:t>Chop. Target 40 seconds.</a:t>
             </a:r>
           </a:p>
           <a:p/>
           <a:p>
             <a:r>
-              <a:t>It’s a freemium model. The free tier runs on free AI models, like the Gemini free tier, Groq and OpenRouter, so students start at no cost and each request costs us nothing.</a:t>
+              <a:t>The heart of it is a tutor you can talk to. You ask in your own words. If it doesn’t click, you keep going: ask for simpler words or an example, like you would with a real tutor. It remembers the page and the conversation, and it asks you a quick question back to check you got it. Then it offers flashcards on that page. In the winter release you can talk to it out loud.</a:t>
             </a:r>
           </a:p>
           <a:p/>
           <a:p>
             <a:r>
-              <a:t>Pro is a monthly or per-term subscription. It unlocks paid models in the model picker, sorted from cheapest to most expensive, so students choose their own trade-off. One explanation costs us about half a cent on Haiku and about two and a half cents on Opus, and a monthly usage limit keeps every Pro plan covered by what the student pays.</a:t>
-            </a:r>
-          </a:p>
-          <a:p/>
-          <a:p>
-            <a:r>
-              <a:t>We’re self-funded, with a budget of up to 150 US dollars over the two terms.</a:t>
-            </a:r>
-          </a:p>
-          <a:p/>
-          <a:p>
-            <a:r>
-              <a:t>Sources:</a:t>
-            </a:r>
-          </a:p>
-          <a:p>
-            <a:r>
-              <a:t>Business Model Analysis (Workshop 2), Business Case and Project Charter (Workshop 3). Costs at current Claude prices per million input / output tokens: Haiku 4.5 US$1 / US$5, Sonnet 5.5 US$2 / US$10, Opus 5.5 US$4 / US$20.</a:t>
+              <a:t>Note: the conversation on the slide is an example to show the idea. Prototype screens are ready on October 20.</a:t>
             </a:r>
           </a:p>
         </p:txBody>
@@ -1651,13 +1617,13 @@
           <a:p/>
           <a:p>
             <a:r>
-              <a:t>Next week, on October 20, we test our low- and high-fidelity prototypes with at least five students. We show a work-in-progress demo at bazaar day on November 24, and Release 1 ships on December 1 with the reader, cited explanations, the model picker, flashcards and quizzes. In the winter we add accounts and Pro, review before exams, voice input and the iPad version, then run a pilot with 15 students.</a:t>
+              <a:t>Students already have good tools, and each one does part of the job. NotebookLM gives cited answers and quizzes, but every file has to be uploaded first. Acrobat answers questions about one PDF at a time and has no practice. ChatGPT and Gemini explain well, but you set up the context again every session. Anki and Quizlet work for review, but you make every card by hand.</a:t>
             </a:r>
           </a:p>
           <a:p/>
           <a:p>
             <a:r>
-              <a:t>We hold ourselves to three numbers: at least 85% of answers accurate to the page, a first useful answer in at least half the time it takes with a chatbot, and at least 20% of pilot students saying they’d pay for Pro.</a:t>
+              <a:t>Our unique value: it explains the page you’re reading, cites it and turns it into practice, straight from your own files. We win on setup time, not on raw answer quality.</a:t>
             </a:r>
           </a:p>
           <a:p/>
@@ -1668,7 +1634,7 @@
           </a:p>
           <a:p>
             <a:r>
-              <a:t>Project Charter objectives and KPIs, Milestone-Based Schedule (Workshop 3). Winter dates are tentative.</a:t>
+              <a:t>Competitor Analysis (Workshop 1) and Business Case (Workshop 3).</a:t>
             </a:r>
           </a:p>
         </p:txBody>
@@ -1694,6 +1660,198 @@
 </file>
 
 <file path=ppt/notesSlides/notesSlide7.xml><?xml version="1.0" encoding="utf-8"?>
+<p:notes xmlns:a="http://schemas.openxmlformats.org/drawingml/2006/main" xmlns:p="http://schemas.openxmlformats.org/presentationml/2006/main" xmlns:r="http://schemas.openxmlformats.org/officeDocument/2006/relationships">
+  <p:cSld>
+    <p:spTree>
+      <p:nvGrpSpPr>
+        <p:cNvPr id="1" name=""/>
+        <p:cNvGrpSpPr/>
+        <p:nvPr/>
+      </p:nvGrpSpPr>
+      <p:grpSpPr>
+        <a:xfrm>
+          <a:off x="0" y="0"/>
+          <a:ext cx="0" cy="0"/>
+          <a:chOff x="0" y="0"/>
+          <a:chExt cx="0" cy="0"/>
+        </a:xfrm>
+      </p:grpSpPr>
+      <p:sp>
+        <p:nvSpPr>
+          <p:cNvPr id="2" name="Slide Image Placeholder 1"/>
+          <p:cNvSpPr>
+            <a:spLocks noGrp="1"/>
+          </p:cNvSpPr>
+          <p:nvPr>
+            <p:ph type="sldImg" idx="3"/>
+          </p:nvPr>
+        </p:nvSpPr>
+        <p:spPr/>
+      </p:sp>
+      <p:sp>
+        <p:nvSpPr>
+          <p:cNvPr id="3" name="Notes Placeholder 2"/>
+          <p:cNvSpPr>
+            <a:spLocks noGrp="1"/>
+          </p:cNvSpPr>
+          <p:nvPr>
+            <p:ph type="body" idx="1"/>
+          </p:nvPr>
+        </p:nvSpPr>
+        <p:spPr/>
+        <p:txBody>
+          <a:bodyPr/>
+          <a:lstStyle/>
+          <a:p>
+            <a:r>
+              <a:t>Chop. Target 35 seconds.</a:t>
+            </a:r>
+          </a:p>
+          <a:p/>
+          <a:p>
+            <a:r>
+              <a:t>It’s a freemium model. The free tier runs on free AI models, like the Gemini free tier, Groq and OpenRouter, so students start at no cost and each request costs us nothing.</a:t>
+            </a:r>
+          </a:p>
+          <a:p/>
+          <a:p>
+            <a:r>
+              <a:t>Pro is a monthly or per-term subscription that unlocks paid models, sorted from cheapest to most expensive. One explanation costs us between half a cent and two and a half cents, and a monthly usage limit keeps every Pro plan covered by what the student pays.</a:t>
+            </a:r>
+          </a:p>
+          <a:p/>
+          <a:p>
+            <a:r>
+              <a:t>We’re self-funded, with a budget of up to 150 US dollars over the two terms.</a:t>
+            </a:r>
+          </a:p>
+          <a:p/>
+          <a:p>
+            <a:r>
+              <a:t>Sources:</a:t>
+            </a:r>
+          </a:p>
+          <a:p>
+            <a:r>
+              <a:t>Business Model Analysis (Workshop 2), Business Case and Project Charter (Workshop 3). Costs at current Claude prices per million input / output tokens: Haiku 4.5 US$1 / US$5, Sonnet 5.5 US$2 / US$10, Opus 5.5 US$4 / US$20.</a:t>
+            </a:r>
+          </a:p>
+        </p:txBody>
+      </p:sp>
+      <p:sp>
+        <p:nvSpPr>
+          <p:cNvPr id="4" name="Slide Number Placeholder 3"/>
+          <p:cNvSpPr>
+            <a:spLocks noGrp="1"/>
+          </p:cNvSpPr>
+          <p:nvPr>
+            <p:ph type="sldNum" idx="12"/>
+          </p:nvPr>
+        </p:nvSpPr>
+        <p:spPr/>
+      </p:sp>
+    </p:spTree>
+  </p:cSld>
+  <p:clrMapOvr>
+    <a:masterClrMapping/>
+  </p:clrMapOvr>
+</p:notes>
+</file>
+
+<file path=ppt/notesSlides/notesSlide8.xml><?xml version="1.0" encoding="utf-8"?>
+<p:notes xmlns:a="http://schemas.openxmlformats.org/drawingml/2006/main" xmlns:p="http://schemas.openxmlformats.org/presentationml/2006/main" xmlns:r="http://schemas.openxmlformats.org/officeDocument/2006/relationships">
+  <p:cSld>
+    <p:spTree>
+      <p:nvGrpSpPr>
+        <p:cNvPr id="1" name=""/>
+        <p:cNvGrpSpPr/>
+        <p:nvPr/>
+      </p:nvGrpSpPr>
+      <p:grpSpPr>
+        <a:xfrm>
+          <a:off x="0" y="0"/>
+          <a:ext cx="0" cy="0"/>
+          <a:chOff x="0" y="0"/>
+          <a:chExt cx="0" cy="0"/>
+        </a:xfrm>
+      </p:grpSpPr>
+      <p:sp>
+        <p:nvSpPr>
+          <p:cNvPr id="2" name="Slide Image Placeholder 1"/>
+          <p:cNvSpPr>
+            <a:spLocks noGrp="1"/>
+          </p:cNvSpPr>
+          <p:nvPr>
+            <p:ph type="sldImg" idx="3"/>
+          </p:nvPr>
+        </p:nvSpPr>
+        <p:spPr/>
+      </p:sp>
+      <p:sp>
+        <p:nvSpPr>
+          <p:cNvPr id="3" name="Notes Placeholder 2"/>
+          <p:cNvSpPr>
+            <a:spLocks noGrp="1"/>
+          </p:cNvSpPr>
+          <p:nvPr>
+            <p:ph type="body" idx="1"/>
+          </p:nvPr>
+        </p:nvSpPr>
+        <p:spPr/>
+        <p:txBody>
+          <a:bodyPr/>
+          <a:lstStyle/>
+          <a:p>
+            <a:r>
+              <a:t>Chop. Target 30 seconds.</a:t>
+            </a:r>
+          </a:p>
+          <a:p/>
+          <a:p>
+            <a:r>
+              <a:t>Next week, on October 20, we test our prototypes with at least five students. We demo at bazaar day on November 24, and Release 1 ships on December 1. In the winter we add Pro, review before exams, voice and iPad, then run a pilot with 15 students.</a:t>
+            </a:r>
+          </a:p>
+          <a:p/>
+          <a:p>
+            <a:r>
+              <a:t>We hold ourselves to three numbers: at least 85% of answers accurate to the page, a first useful answer in at least half the time it takes with a chatbot, and at least 20% of pilot students saying they’d pay for Pro.</a:t>
+            </a:r>
+          </a:p>
+          <a:p/>
+          <a:p>
+            <a:r>
+              <a:t>Sources:</a:t>
+            </a:r>
+          </a:p>
+          <a:p>
+            <a:r>
+              <a:t>Project Charter objectives and KPIs, Milestone-Based Schedule (Workshop 3). Winter dates are tentative.</a:t>
+            </a:r>
+          </a:p>
+        </p:txBody>
+      </p:sp>
+      <p:sp>
+        <p:nvSpPr>
+          <p:cNvPr id="4" name="Slide Number Placeholder 3"/>
+          <p:cNvSpPr>
+            <a:spLocks noGrp="1"/>
+          </p:cNvSpPr>
+          <p:nvPr>
+            <p:ph type="sldNum" idx="12"/>
+          </p:nvPr>
+        </p:nvSpPr>
+        <p:spPr/>
+      </p:sp>
+    </p:spTree>
+  </p:cSld>
+  <p:clrMapOvr>
+    <a:masterClrMapping/>
+  </p:clrMapOvr>
+</p:notes>
+</file>
+
+<file path=ppt/notesSlides/notesSlide9.xml><?xml version="1.0" encoding="utf-8"?>
 <p:notes xmlns:a="http://schemas.openxmlformats.org/drawingml/2006/main" xmlns:p="http://schemas.openxmlformats.org/presentationml/2006/main" xmlns:r="http://schemas.openxmlformats.org/officeDocument/2006/relationships">
   <p:cSld>
     <p:spTree>
@@ -3912,7 +4070,7 @@
                 <a:cs typeface="Calibri"/>
                 <a:sym typeface="Calibri"/>
               </a:rPr>
-              <a:t>Built for university students who study from course PDFs, starting at the U of R</a:t>
+              <a:t>Goal: a faster path from reading a page to understanding it</a:t>
             </a:r>
           </a:p>
         </p:txBody>
@@ -4002,7 +4160,7 @@
       <p:grpSpPr/>
       <p:sp>
         <p:nvSpPr>
-          <p:cNvPr id="191" name="Google Shape;191;p9"/>
+          <p:cNvPr id="152" name="Google Shape;152;p7"/>
           <p:cNvSpPr/>
           <p:nvPr/>
         </p:nvSpPr>
@@ -4044,14 +4202,14 @@
                 <a:cs typeface="Calibri"/>
                 <a:sym typeface="Calibri"/>
               </a:rPr>
-              <a:t>From the page to practice, in one app</a:t>
-            </a:r>
-          </a:p>
-        </p:txBody>
-      </p:sp>
-      <p:sp>
-        <p:nvSpPr>
-          <p:cNvPr id="192" name="Google Shape;192;p9"/>
+              <a:t>Who we’re building it for</a:t>
+            </a:r>
+          </a:p>
+        </p:txBody>
+      </p:sp>
+      <p:sp>
+        <p:nvSpPr>
+          <p:cNvPr id="153" name="Google Shape;153;p7"/>
           <p:cNvSpPr/>
           <p:nvPr/>
         </p:nvSpPr>
@@ -4096,7 +4254,7 @@
       </p:sp>
       <p:sp>
         <p:nvSpPr>
-          <p:cNvPr id="193" name="Google Shape;193;p9"/>
+          <p:cNvPr id="154" name="Google Shape;154;p7"/>
           <p:cNvSpPr/>
           <p:nvPr/>
         </p:nvSpPr>
@@ -4138,14 +4296,14 @@
                 <a:cs typeface="Calibri"/>
                 <a:sym typeface="Calibri"/>
               </a:rPr>
-              <a:t>WHAT + HOW</a:t>
+              <a:t>WHO</a:t>
             </a:r>
           </a:p>
         </p:txBody>
       </p:sp>
       <p:cxnSp>
         <p:nvCxnSpPr>
-          <p:cNvPr id="194" name="Google Shape;194;p9"/>
+          <p:cNvPr id="155" name="Google Shape;155;p7"/>
           <p:cNvCxnSpPr/>
           <p:nvPr/>
         </p:nvCxnSpPr>
@@ -4171,7 +4329,7 @@
       </p:cxnSp>
       <p:sp>
         <p:nvSpPr>
-          <p:cNvPr id="195" name="Google Shape;195;p9"/>
+          <p:cNvPr id="156" name="Google Shape;156;p7"/>
           <p:cNvSpPr/>
           <p:nvPr/>
         </p:nvSpPr>
@@ -4220,14 +4378,14 @@
       </p:sp>
       <p:sp>
         <p:nvSpPr>
-          <p:cNvPr id="196" name="Google Shape;196;p9"/>
+          <p:cNvPr id="157" name="Google Shape;157;p7"/>
           <p:cNvSpPr/>
           <p:nvPr/>
         </p:nvSpPr>
         <p:spPr>
           <a:xfrm>
-            <a:off x="523875" y="1323975"/>
-            <a:ext cx="9525000" cy="295275"/>
+            <a:off x="523875" y="1409700"/>
+            <a:ext cx="6191250" cy="923925"/>
           </a:xfrm>
           <a:prstGeom prst="rect">
             <a:avLst/>
@@ -4253,7 +4411,7 @@
               <a:buNone/>
             </a:pPr>
             <a:r>
-              <a:rPr b="1" lang="en-US" sz="2025">
+              <a:rPr b="1" lang="en-US" sz="2850">
                 <a:solidFill>
                   <a:srgbClr val="154734"/>
                 </a:solidFill>
@@ -4262,139 +4420,217 @@
                 <a:cs typeface="Calibri"/>
                 <a:sym typeface="Calibri"/>
               </a:rPr>
-              <a:t>How a study session works</a:t>
-            </a:r>
-          </a:p>
-        </p:txBody>
-      </p:sp>
-      <p:sp>
-        <p:nvSpPr>
-          <p:cNvPr id="197" name="Google Shape;197;p9"/>
+              <a:t>U of R undergraduates who study from course PDFs</a:t>
+            </a:r>
+          </a:p>
+        </p:txBody>
+      </p:sp>
+      <p:sp>
+        <p:nvSpPr>
+          <p:cNvPr id="159" name="Google Shape;159;p7"/>
           <p:cNvSpPr/>
           <p:nvPr/>
         </p:nvSpPr>
         <p:spPr>
           <a:xfrm>
-            <a:off x="523875" y="1866900"/>
-            <a:ext cx="2838450" cy="1076325"/>
+            <a:off x="523875" y="4206240"/>
+            <a:ext cx="6076950" cy="276225"/>
+          </a:xfrm>
+          <a:prstGeom prst="rect">
+            <a:avLst/>
+          </a:prstGeom>
+          <a:noFill/>
+          <a:ln>
+            <a:noFill/>
+          </a:ln>
+        </p:spPr>
+        <p:txBody>
+          <a:bodyPr anchorCtr="0" anchor="t" bIns="0" lIns="0" spcFirstLastPara="1" rIns="0" wrap="square" tIns="0">
+            <a:noAutofit/>
+          </a:bodyPr>
+          <a:lstStyle/>
+          <a:p>
+            <a:pPr indent="0" lvl="0" marL="0" marR="0" rtl="0" algn="l">
+              <a:spcBef>
+                <a:spcPts val="0"/>
+              </a:spcBef>
+              <a:spcAft>
+                <a:spcPts val="0"/>
+              </a:spcAft>
+              <a:buNone/>
+            </a:pPr>
+            <a:r>
+              <a:rPr b="1" lang="en-US" sz="1575">
+                <a:solidFill>
+                  <a:srgbClr val="154734"/>
+                </a:solidFill>
+                <a:latin typeface="Calibri"/>
+                <a:ea typeface="Calibri"/>
+                <a:cs typeface="Calibri"/>
+                <a:sym typeface="Calibri"/>
+              </a:rPr>
+              <a:t>SECOND GROUP</a:t>
+            </a:r>
+          </a:p>
+        </p:txBody>
+      </p:sp>
+      <p:sp>
+        <p:nvSpPr>
+          <p:cNvPr id="160" name="Google Shape;160;p7"/>
+          <p:cNvSpPr/>
+          <p:nvPr/>
+        </p:nvSpPr>
+        <p:spPr>
+          <a:xfrm>
+            <a:off x="523875" y="4526280"/>
+            <a:ext cx="6038850" cy="822960"/>
+          </a:xfrm>
+          <a:prstGeom prst="rect">
+            <a:avLst/>
+          </a:prstGeom>
+          <a:noFill/>
+          <a:ln>
+            <a:noFill/>
+          </a:ln>
+        </p:spPr>
+        <p:txBody>
+          <a:bodyPr anchorCtr="0" anchor="t" bIns="0" lIns="0" spcFirstLastPara="1" rIns="0" wrap="square" tIns="0">
+            <a:noAutofit/>
+          </a:bodyPr>
+          <a:lstStyle/>
+          <a:p>
+            <a:pPr indent="0" lvl="0" marL="0" marR="0" rtl="0" algn="l">
+              <a:spcBef>
+                <a:spcPts val="0"/>
+              </a:spcBef>
+              <a:spcAft>
+                <a:spcPts val="0"/>
+              </a:spcAft>
+              <a:buNone/>
+            </a:pPr>
+            <a:r>
+              <a:rPr b="0" lang="en-US" sz="2175">
+                <a:solidFill>
+                  <a:srgbClr val="1A1A1A"/>
+                </a:solidFill>
+                <a:latin typeface="Calibri"/>
+                <a:ea typeface="Calibri"/>
+                <a:cs typeface="Calibri"/>
+                <a:sym typeface="Calibri"/>
+              </a:rPr>
+              <a:t>Graduate and thesis students who read lots of papers</a:t>
+            </a:r>
+          </a:p>
+        </p:txBody>
+      </p:sp>
+      <p:pic>
+        <p:nvPicPr>
+          <p:cNvPr id="161" name="Google Shape;161;p7"/>
+          <p:cNvPicPr preferRelativeResize="0"/>
+          <p:nvPr/>
+        </p:nvPicPr>
+        <p:blipFill rotWithShape="1">
+          <a:blip r:embed="rId2">
+            <a:alphaModFix/>
+          </a:blip>
+          <a:srcRect b="0" l="15040" r="15040" t="0"/>
+          <a:stretch/>
+        </p:blipFill>
+        <p:spPr>
+          <a:xfrm>
+            <a:off x="7143750" y="1390650"/>
+            <a:ext cx="4524375" cy="4314825"/>
+          </a:xfrm>
+          <a:prstGeom prst="rect">
+            <a:avLst/>
+          </a:prstGeom>
+          <a:noFill/>
+          <a:ln>
+            <a:noFill/>
+          </a:ln>
+        </p:spPr>
+      </p:pic>
+      <p:sp>
+        <p:nvSpPr>
+          <p:cNvPr id="162" name="Google Shape;162;p7"/>
+          <p:cNvSpPr/>
+          <p:nvPr/>
+        </p:nvSpPr>
+        <p:spPr>
+          <a:xfrm>
+            <a:off x="523875" y="5876925"/>
+            <a:ext cx="11144250" cy="476250"/>
           </a:xfrm>
           <a:prstGeom prst="roundRect">
             <a:avLst>
-              <a:gd fmla="val 8850" name="adj"/>
-            </a:avLst>
-          </a:prstGeom>
-          <a:solidFill>
-            <a:srgbClr val="EAF2EE"/>
-          </a:solidFill>
-          <a:ln cap="flat" cmpd="sng" w="13325">
-            <a:solidFill>
-              <a:srgbClr val="154734"/>
-            </a:solidFill>
-            <a:prstDash val="solid"/>
-            <a:round/>
-            <a:headEnd len="sm" w="sm" type="none"/>
-            <a:tailEnd len="sm" w="sm" type="none"/>
-          </a:ln>
-        </p:spPr>
-        <p:txBody>
-          <a:bodyPr anchorCtr="0" anchor="ctr" bIns="95250" lIns="114300" spcFirstLastPara="1" rIns="114300" wrap="square" tIns="95250">
-            <a:noAutofit/>
-          </a:bodyPr>
-          <a:lstStyle/>
-          <a:p>
-            <a:pPr indent="0" lvl="0" marL="0" marR="0" rtl="0" algn="ctr">
-              <a:spcBef>
-                <a:spcPts val="0"/>
-              </a:spcBef>
-              <a:spcAft>
-                <a:spcPts val="0"/>
-              </a:spcAft>
-              <a:buNone/>
-            </a:pPr>
-            <a:r>
-              <a:rPr b="1" lang="en-US" sz="1800">
-                <a:solidFill>
-                  <a:srgbClr val="154734"/>
-                </a:solidFill>
-                <a:latin typeface="Calibri"/>
-                <a:ea typeface="Calibri"/>
-                <a:cs typeface="Calibri"/>
-                <a:sym typeface="Calibri"/>
-              </a:rPr>
-              <a:t>Your course folders</a:t>
-            </a:r>
-          </a:p>
-          <a:p>
-            <a:pPr indent="0" lvl="0" marL="0" marR="0" rtl="0" algn="ctr">
-              <a:spcBef>
-                <a:spcPts val="0"/>
-              </a:spcBef>
-              <a:spcAft>
-                <a:spcPts val="0"/>
-              </a:spcAft>
-              <a:buNone/>
-            </a:pPr>
-            <a:r>
-              <a:rPr b="1" lang="en-US" sz="1800">
-                <a:solidFill>
-                  <a:srgbClr val="154734"/>
-                </a:solidFill>
-                <a:latin typeface="Calibri"/>
-                <a:ea typeface="Calibri"/>
-                <a:cs typeface="Calibri"/>
-                <a:sym typeface="Calibri"/>
-              </a:rPr>
-              <a:t>PDFs on your laptop</a:t>
-            </a:r>
-          </a:p>
-        </p:txBody>
-      </p:sp>
-      <p:sp>
-        <p:nvSpPr>
-          <p:cNvPr id="198" name="Google Shape;198;p9"/>
-          <p:cNvSpPr/>
-          <p:nvPr/>
-        </p:nvSpPr>
-        <p:spPr>
-          <a:xfrm>
-            <a:off x="4143375" y="1866900"/>
-            <a:ext cx="3048000" cy="1076325"/>
-          </a:xfrm>
-          <a:prstGeom prst="roundRect">
-            <a:avLst>
-              <a:gd fmla="val 8850" name="adj"/>
+              <a:gd fmla="val 24000" name="adj"/>
             </a:avLst>
           </a:prstGeom>
           <a:solidFill>
             <a:srgbClr val="FFB81C"/>
           </a:solidFill>
-          <a:ln cap="flat" cmpd="sng" w="13325">
-            <a:solidFill>
-              <a:srgbClr val="154734"/>
-            </a:solidFill>
-            <a:prstDash val="solid"/>
-            <a:round/>
-            <a:headEnd len="sm" w="sm" type="none"/>
-            <a:tailEnd len="sm" w="sm" type="none"/>
-          </a:ln>
-        </p:spPr>
-        <p:txBody>
-          <a:bodyPr anchorCtr="0" anchor="ctr" bIns="95250" lIns="114300" spcFirstLastPara="1" rIns="114300" wrap="square" tIns="95250">
-            <a:noAutofit/>
-          </a:bodyPr>
-          <a:lstStyle/>
-          <a:p>
-            <a:pPr indent="0" lvl="0" marL="0" marR="0" rtl="0" algn="ctr">
-              <a:spcBef>
-                <a:spcPts val="0"/>
-              </a:spcBef>
-              <a:spcAft>
-                <a:spcPts val="0"/>
-              </a:spcAft>
-              <a:buNone/>
-            </a:pPr>
-            <a:r>
-              <a:rPr b="1" lang="en-US" sz="1800">
+          <a:ln>
+            <a:noFill/>
+          </a:ln>
+        </p:spPr>
+        <p:txBody>
+          <a:bodyPr anchorCtr="0" anchor="ctr" bIns="91425" lIns="91425" spcFirstLastPara="1" rIns="91425" wrap="square" tIns="91425">
+            <a:noAutofit/>
+          </a:bodyPr>
+          <a:lstStyle/>
+          <a:p>
+            <a:pPr indent="0" lvl="0" marL="0" rtl="0" algn="l">
+              <a:spcBef>
+                <a:spcPts val="0"/>
+              </a:spcBef>
+              <a:spcAft>
+                <a:spcPts val="0"/>
+              </a:spcAft>
+              <a:buNone/>
+            </a:pPr>
+            <a:r>
+              <a:t/>
+            </a:r>
+            <a:endParaRPr/>
+          </a:p>
+        </p:txBody>
+      </p:sp>
+      <p:sp>
+        <p:nvSpPr>
+          <p:cNvPr id="163" name="Google Shape;163;p7"/>
+          <p:cNvSpPr/>
+          <p:nvPr/>
+        </p:nvSpPr>
+        <p:spPr>
+          <a:xfrm>
+            <a:off x="752475" y="5977433"/>
+            <a:ext cx="10687050" cy="274320"/>
+          </a:xfrm>
+          <a:prstGeom prst="rect">
+            <a:avLst/>
+          </a:prstGeom>
+          <a:noFill/>
+          <a:ln>
+            <a:noFill/>
+          </a:ln>
+        </p:spPr>
+        <p:txBody>
+          <a:bodyPr anchorCtr="0" anchor="t" bIns="0" lIns="0" spcFirstLastPara="1" rIns="0" wrap="square" tIns="0">
+            <a:noAutofit/>
+          </a:bodyPr>
+          <a:lstStyle/>
+          <a:p>
+            <a:pPr indent="0" lvl="0" marL="0" marR="0" rtl="0" algn="l">
+              <a:spcBef>
+                <a:spcPts val="0"/>
+              </a:spcBef>
+              <a:spcAft>
+                <a:spcPts val="0"/>
+              </a:spcAft>
+              <a:buNone/>
+            </a:pPr>
+            <a:r>
+              <a:rPr b="1" lang="en-US" sz="1725">
                 <a:solidFill>
                   <a:srgbClr val="154734"/>
                 </a:solidFill>
@@ -4403,406 +4639,21 @@
                 <a:cs typeface="Calibri"/>
                 <a:sym typeface="Calibri"/>
               </a:rPr>
-              <a:t>Open a PDF</a:t>
-            </a:r>
-          </a:p>
-          <a:p>
-            <a:pPr indent="0" lvl="0" marL="0" marR="0" rtl="0" algn="ctr">
-              <a:spcBef>
-                <a:spcPts val="0"/>
-              </a:spcBef>
-              <a:spcAft>
-                <a:spcPts val="0"/>
-              </a:spcAft>
-              <a:buNone/>
-            </a:pPr>
-            <a:r>
-              <a:rPr b="1" lang="en-US" sz="1800">
-                <a:solidFill>
-                  <a:srgbClr val="154734"/>
-                </a:solidFill>
-                <a:latin typeface="Calibri"/>
-                <a:ea typeface="Calibri"/>
-                <a:cs typeface="Calibri"/>
-                <a:sym typeface="Calibri"/>
-              </a:rPr>
-              <a:t>Select a page or passage</a:t>
-            </a:r>
-          </a:p>
-        </p:txBody>
-      </p:sp>
-      <p:sp>
-        <p:nvSpPr>
-          <p:cNvPr id="199" name="Google Shape;199;p9"/>
+              <a:t>First users: classmates testing it on their own course files</a:t>
+            </a:r>
+          </a:p>
+        </p:txBody>
+      </p:sp>
+      <p:sp xmlns:ahyp="http://schemas.microsoft.com/office/drawing/2018/hyperlinkcolor">
+        <p:nvSpPr>
+          <p:cNvPr id="164" name="Google Shape;164;p7"/>
           <p:cNvSpPr/>
           <p:nvPr/>
         </p:nvSpPr>
         <p:spPr>
           <a:xfrm>
-            <a:off x="7972425" y="1866900"/>
-            <a:ext cx="3695700" cy="1076325"/>
-          </a:xfrm>
-          <a:prstGeom prst="roundRect">
-            <a:avLst>
-              <a:gd fmla="val 8850" name="adj"/>
-            </a:avLst>
-          </a:prstGeom>
-          <a:solidFill>
-            <a:srgbClr val="EAF2EE"/>
-          </a:solidFill>
-          <a:ln cap="flat" cmpd="sng" w="13325">
-            <a:solidFill>
-              <a:srgbClr val="154734"/>
-            </a:solidFill>
-            <a:prstDash val="solid"/>
-            <a:round/>
-            <a:headEnd len="sm" w="sm" type="none"/>
-            <a:tailEnd len="sm" w="sm" type="none"/>
-          </a:ln>
-        </p:spPr>
-        <p:txBody>
-          <a:bodyPr anchorCtr="0" anchor="ctr" bIns="95250" lIns="114300" spcFirstLastPara="1" rIns="114300" wrap="square" tIns="95250">
-            <a:noAutofit/>
-          </a:bodyPr>
-          <a:lstStyle/>
-          <a:p>
-            <a:pPr indent="0" lvl="0" marL="0" marR="0" rtl="0" algn="ctr">
-              <a:spcBef>
-                <a:spcPts val="0"/>
-              </a:spcBef>
-              <a:spcAft>
-                <a:spcPts val="0"/>
-              </a:spcAft>
-              <a:buNone/>
-            </a:pPr>
-            <a:r>
-              <a:rPr b="1" lang="en-US" sz="1800">
-                <a:solidFill>
-                  <a:srgbClr val="154734"/>
-                </a:solidFill>
-                <a:latin typeface="Calibri"/>
-                <a:ea typeface="Calibri"/>
-                <a:cs typeface="Calibri"/>
-                <a:sym typeface="Calibri"/>
-              </a:rPr>
-              <a:t>Ask a question</a:t>
-            </a:r>
-          </a:p>
-          <a:p>
-            <a:pPr indent="0" lvl="0" marL="0" marR="0" rtl="0" algn="ctr">
-              <a:spcBef>
-                <a:spcPts val="0"/>
-              </a:spcBef>
-              <a:spcAft>
-                <a:spcPts val="0"/>
-              </a:spcAft>
-              <a:buNone/>
-            </a:pPr>
-            <a:r>
-              <a:rPr b="1" lang="en-US" sz="1800">
-                <a:solidFill>
-                  <a:srgbClr val="154734"/>
-                </a:solidFill>
-                <a:latin typeface="Calibri"/>
-                <a:ea typeface="Calibri"/>
-                <a:cs typeface="Calibri"/>
-                <a:sym typeface="Calibri"/>
-              </a:rPr>
-              <a:t>Answer with its page number</a:t>
-            </a:r>
-          </a:p>
-        </p:txBody>
-      </p:sp>
-      <p:cxnSp>
-        <p:nvCxnSpPr>
-          <p:cNvPr id="200" name="Google Shape;200;p9"/>
-          <p:cNvCxnSpPr>
-            <a:stCxn id="197" idx="3"/>
-            <a:endCxn id="198" idx="1"/>
-          </p:cNvCxnSpPr>
-          <p:nvPr/>
-        </p:nvCxnSpPr>
-        <p:spPr>
-          <a:xfrm>
-            <a:off x="3362325" y="2405063"/>
-            <a:ext cx="781200" cy="0"/>
-          </a:xfrm>
-          <a:prstGeom prst="straightConnector1">
-            <a:avLst/>
-          </a:prstGeom>
-          <a:noFill/>
-          <a:ln cap="flat" cmpd="sng" w="23800">
-            <a:solidFill>
-              <a:srgbClr val="154734"/>
-            </a:solidFill>
-            <a:prstDash val="solid"/>
-            <a:round/>
-            <a:headEnd len="sm" w="sm" type="none"/>
-            <a:tailEnd len="med" w="med" type="stealth"/>
-          </a:ln>
-        </p:spPr>
-      </p:cxnSp>
-      <p:cxnSp>
-        <p:nvCxnSpPr>
-          <p:cNvPr id="201" name="Google Shape;201;p9"/>
-          <p:cNvCxnSpPr>
-            <a:stCxn id="198" idx="3"/>
-            <a:endCxn id="199" idx="1"/>
-          </p:cNvCxnSpPr>
-          <p:nvPr/>
-        </p:nvCxnSpPr>
-        <p:spPr>
-          <a:xfrm>
-            <a:off x="7191375" y="2405063"/>
-            <a:ext cx="781200" cy="0"/>
-          </a:xfrm>
-          <a:prstGeom prst="straightConnector1">
-            <a:avLst/>
-          </a:prstGeom>
-          <a:noFill/>
-          <a:ln cap="flat" cmpd="sng" w="23800">
-            <a:solidFill>
-              <a:srgbClr val="154734"/>
-            </a:solidFill>
-            <a:prstDash val="solid"/>
-            <a:round/>
-            <a:headEnd len="sm" w="sm" type="none"/>
-            <a:tailEnd len="med" w="med" type="stealth"/>
-          </a:ln>
-        </p:spPr>
-      </p:cxnSp>
-      <p:sp>
-        <p:nvSpPr>
-          <p:cNvPr id="202" name="Google Shape;202;p9"/>
-          <p:cNvSpPr/>
-          <p:nvPr/>
-        </p:nvSpPr>
-        <p:spPr>
-          <a:xfrm>
-            <a:off x="7972425" y="3781425"/>
-            <a:ext cx="3695700" cy="942975"/>
-          </a:xfrm>
-          <a:prstGeom prst="roundRect">
-            <a:avLst>
-              <a:gd fmla="val 10101" name="adj"/>
-            </a:avLst>
-          </a:prstGeom>
-          <a:solidFill>
-            <a:srgbClr val="EAF2EE"/>
-          </a:solidFill>
-          <a:ln cap="flat" cmpd="sng" w="13325">
-            <a:solidFill>
-              <a:srgbClr val="154734"/>
-            </a:solidFill>
-            <a:prstDash val="solid"/>
-            <a:round/>
-            <a:headEnd len="sm" w="sm" type="none"/>
-            <a:tailEnd len="sm" w="sm" type="none"/>
-          </a:ln>
-        </p:spPr>
-        <p:txBody>
-          <a:bodyPr anchorCtr="0" anchor="ctr" bIns="95250" lIns="114300" spcFirstLastPara="1" rIns="114300" wrap="square" tIns="95250">
-            <a:noAutofit/>
-          </a:bodyPr>
-          <a:lstStyle/>
-          <a:p>
-            <a:pPr indent="0" lvl="0" marL="0" marR="0" rtl="0" algn="ctr">
-              <a:spcBef>
-                <a:spcPts val="0"/>
-              </a:spcBef>
-              <a:spcAft>
-                <a:spcPts val="0"/>
-              </a:spcAft>
-              <a:buNone/>
-            </a:pPr>
-            <a:r>
-              <a:rPr b="1" lang="en-US" sz="1800">
-                <a:solidFill>
-                  <a:srgbClr val="154734"/>
-                </a:solidFill>
-                <a:latin typeface="Calibri"/>
-                <a:ea typeface="Calibri"/>
-                <a:cs typeface="Calibri"/>
-                <a:sym typeface="Calibri"/>
-              </a:rPr>
-              <a:t>Practise</a:t>
-            </a:r>
-          </a:p>
-          <a:p>
-            <a:pPr indent="0" lvl="0" marL="0" marR="0" rtl="0" algn="ctr">
-              <a:spcBef>
-                <a:spcPts val="0"/>
-              </a:spcBef>
-              <a:spcAft>
-                <a:spcPts val="0"/>
-              </a:spcAft>
-              <a:buNone/>
-            </a:pPr>
-            <a:r>
-              <a:rPr b="1" lang="en-US" sz="1800">
-                <a:solidFill>
-                  <a:srgbClr val="154734"/>
-                </a:solidFill>
-                <a:latin typeface="Calibri"/>
-                <a:ea typeface="Calibri"/>
-                <a:cs typeface="Calibri"/>
-                <a:sym typeface="Calibri"/>
-              </a:rPr>
-              <a:t>Flashcards and a quiz</a:t>
-            </a:r>
-          </a:p>
-        </p:txBody>
-      </p:sp>
-      <p:sp>
-        <p:nvSpPr>
-          <p:cNvPr id="203" name="Google Shape;203;p9"/>
-          <p:cNvSpPr/>
-          <p:nvPr/>
-        </p:nvSpPr>
-        <p:spPr>
-          <a:xfrm>
-            <a:off x="4143375" y="3781425"/>
-            <a:ext cx="3048000" cy="942975"/>
-          </a:xfrm>
-          <a:prstGeom prst="roundRect">
-            <a:avLst>
-              <a:gd fmla="val 10101" name="adj"/>
-            </a:avLst>
-          </a:prstGeom>
-          <a:solidFill>
-            <a:srgbClr val="EAF2EE"/>
-          </a:solidFill>
-          <a:ln cap="flat" cmpd="sng" w="13325">
-            <a:solidFill>
-              <a:srgbClr val="154734"/>
-            </a:solidFill>
-            <a:prstDash val="solid"/>
-            <a:round/>
-            <a:headEnd len="sm" w="sm" type="none"/>
-            <a:tailEnd len="sm" w="sm" type="none"/>
-          </a:ln>
-        </p:spPr>
-        <p:txBody>
-          <a:bodyPr anchorCtr="0" anchor="ctr" bIns="95250" lIns="114300" spcFirstLastPara="1" rIns="114300" wrap="square" tIns="95250">
-            <a:noAutofit/>
-          </a:bodyPr>
-          <a:lstStyle/>
-          <a:p>
-            <a:pPr indent="0" lvl="0" marL="0" marR="0" rtl="0" algn="ctr">
-              <a:spcBef>
-                <a:spcPts val="0"/>
-              </a:spcBef>
-              <a:spcAft>
-                <a:spcPts val="0"/>
-              </a:spcAft>
-              <a:buNone/>
-            </a:pPr>
-            <a:r>
-              <a:rPr b="1" lang="en-US" sz="1800">
-                <a:solidFill>
-                  <a:srgbClr val="154734"/>
-                </a:solidFill>
-                <a:latin typeface="Calibri"/>
-                <a:ea typeface="Calibri"/>
-                <a:cs typeface="Calibri"/>
-                <a:sym typeface="Calibri"/>
-              </a:rPr>
-              <a:t>Plan review</a:t>
-            </a:r>
-          </a:p>
-          <a:p>
-            <a:pPr indent="0" lvl="0" marL="0" marR="0" rtl="0" algn="ctr">
-              <a:spcBef>
-                <a:spcPts val="0"/>
-              </a:spcBef>
-              <a:spcAft>
-                <a:spcPts val="0"/>
-              </a:spcAft>
-              <a:buNone/>
-            </a:pPr>
-            <a:r>
-              <a:rPr b="1" lang="en-US" sz="1800">
-                <a:solidFill>
-                  <a:srgbClr val="154734"/>
-                </a:solidFill>
-                <a:latin typeface="Calibri"/>
-                <a:ea typeface="Calibri"/>
-                <a:cs typeface="Calibri"/>
-                <a:sym typeface="Calibri"/>
-              </a:rPr>
-              <a:t>Before each exam</a:t>
-            </a:r>
-          </a:p>
-        </p:txBody>
-      </p:sp>
-      <p:cxnSp>
-        <p:nvCxnSpPr>
-          <p:cNvPr id="204" name="Google Shape;204;p9"/>
-          <p:cNvCxnSpPr>
-            <a:stCxn id="199" idx="2"/>
-            <a:endCxn id="202" idx="0"/>
-          </p:cNvCxnSpPr>
-          <p:nvPr/>
-        </p:nvCxnSpPr>
-        <p:spPr>
-          <a:xfrm>
-            <a:off x="9820275" y="2943225"/>
-            <a:ext cx="0" cy="838200"/>
-          </a:xfrm>
-          <a:prstGeom prst="straightConnector1">
-            <a:avLst/>
-          </a:prstGeom>
-          <a:noFill/>
-          <a:ln cap="flat" cmpd="sng" w="23800">
-            <a:solidFill>
-              <a:srgbClr val="154734"/>
-            </a:solidFill>
-            <a:prstDash val="solid"/>
-            <a:round/>
-            <a:headEnd len="sm" w="sm" type="none"/>
-            <a:tailEnd len="med" w="med" type="stealth"/>
-          </a:ln>
-        </p:spPr>
-      </p:cxnSp>
-      <p:cxnSp>
-        <p:nvCxnSpPr>
-          <p:cNvPr id="205" name="Google Shape;205;p9"/>
-          <p:cNvCxnSpPr>
-            <a:stCxn id="202" idx="1"/>
-            <a:endCxn id="203" idx="3"/>
-          </p:cNvCxnSpPr>
-          <p:nvPr/>
-        </p:nvCxnSpPr>
-        <p:spPr>
-          <a:xfrm rot="10800000">
-            <a:off x="7191225" y="4252913"/>
-            <a:ext cx="781200" cy="0"/>
-          </a:xfrm>
-          <a:prstGeom prst="straightConnector1">
-            <a:avLst/>
-          </a:prstGeom>
-          <a:noFill/>
-          <a:ln cap="flat" cmpd="sng" w="23800">
-            <a:solidFill>
-              <a:srgbClr val="154734"/>
-            </a:solidFill>
-            <a:prstDash val="solid"/>
-            <a:round/>
-            <a:headEnd len="sm" w="sm" type="none"/>
-            <a:tailEnd len="med" w="med" type="stealth"/>
-          </a:ln>
-        </p:spPr>
-      </p:cxnSp>
-      <p:sp>
-        <p:nvSpPr>
-          <p:cNvPr id="206" name="Google Shape;206;p9"/>
-          <p:cNvSpPr/>
-          <p:nvPr/>
-        </p:nvSpPr>
-        <p:spPr>
-          <a:xfrm>
-            <a:off x="523875" y="3609975"/>
-            <a:ext cx="2809875" cy="800100"/>
+            <a:off x="523875" y="6486525"/>
+            <a:ext cx="10382250" cy="219075"/>
           </a:xfrm>
           <a:prstGeom prst="rect">
             <a:avLst/>
@@ -4828,53 +4679,38 @@
               <a:buNone/>
             </a:pPr>
             <a:r>
-              <a:rPr b="1" lang="en-US" sz="2025">
-                <a:solidFill>
-                  <a:srgbClr val="154734"/>
-                </a:solidFill>
-                <a:latin typeface="Calibri"/>
-                <a:ea typeface="Calibri"/>
-                <a:cs typeface="Calibri"/>
-                <a:sym typeface="Calibri"/>
-              </a:rPr>
-              <a:t>You choose which</a:t>
-            </a:r>
-          </a:p>
-          <a:p>
-            <a:pPr indent="0" lvl="0" marL="0" marR="0" rtl="0" algn="l">
-              <a:spcBef>
-                <a:spcPts val="0"/>
-              </a:spcBef>
-              <a:spcAft>
-                <a:spcPts val="0"/>
-              </a:spcAft>
-              <a:buNone/>
-            </a:pPr>
-            <a:r>
-              <a:rPr b="1" lang="en-US" sz="2025">
-                <a:solidFill>
-                  <a:srgbClr val="154734"/>
-                </a:solidFill>
-                <a:latin typeface="Calibri"/>
-                <a:ea typeface="Calibri"/>
-                <a:cs typeface="Calibri"/>
-                <a:sym typeface="Calibri"/>
-              </a:rPr>
-              <a:t>folders it can see</a:t>
-            </a:r>
-          </a:p>
-        </p:txBody>
-      </p:sp>
-      <p:sp>
-        <p:nvSpPr>
-          <p:cNvPr id="207" name="Google Shape;207;p9"/>
-          <p:cNvSpPr/>
-          <p:nvPr/>
-        </p:nvSpPr>
-        <p:spPr>
-          <a:xfrm>
-            <a:off x="523875" y="5057775"/>
-            <a:ext cx="11049000" cy="361950"/>
+              <a:rPr b="0" lang="en-US" sz="1125" u="sng">
+                <a:solidFill>
+                  <a:srgbClr val="65736B"/>
+                </a:solidFill>
+                <a:latin typeface="Calibri"/>
+                <a:ea typeface="Calibri"/>
+                <a:cs typeface="Calibri"/>
+                <a:sym typeface="Calibri"/>
+                <a:hlinkClick r:id="rId3">
+                  <a:extLst>
+                    <a:ext uri="{A12FA001-AC4F-418D-AE19-62706E023703}">
+                      <ahyp:hlinkClr val="tx"/>
+                    </a:ext>
+                  </a:extLst>
+                </a:hlinkClick>
+              </a:rPr>
+              <a:t>Illustrative study photo: Yan Krukau / Pexels</a:t>
+            </a:r>
+            <a:endParaRPr/>
+          </a:p>
+        </p:txBody>
+      </p:sp>
+      <p:sp>
+        <p:nvSpPr>
+          <p:cNvPr id="165" name="Text 165"/>
+          <p:cNvSpPr txBox="1"/>
+          <p:nvPr/>
+        </p:nvSpPr>
+        <p:spPr>
+          <a:xfrm>
+            <a:off x="523951" y="2514600"/>
+            <a:ext cx="6309360" cy="1463040"/>
           </a:xfrm>
           <a:prstGeom prst="rect">
             <a:avLst/>
@@ -4890,63 +4726,19 @@
           </a:bodyPr>
           <a:lstStyle/>
           <a:p>
-            <a:pPr indent="0" lvl="0" marL="0" marR="0" rtl="0" algn="l">
-              <a:spcBef>
-                <a:spcPts val="0"/>
-              </a:spcBef>
-              <a:spcAft>
-                <a:spcPts val="0"/>
-              </a:spcAft>
-              <a:buNone/>
-            </a:pPr>
-            <a:r>
-              <a:rPr b="1" lang="en-US" sz="2100">
-                <a:solidFill>
-                  <a:srgbClr val="154734"/>
-                </a:solidFill>
-                <a:latin typeface="Calibri"/>
-                <a:ea typeface="Calibri"/>
-                <a:cs typeface="Calibri"/>
-                <a:sym typeface="Calibri"/>
-              </a:rPr>
-              <a:t>Your files stay on your laptop. Only the passage you select goes to the AI.</a:t>
-            </a:r>
-          </a:p>
-        </p:txBody>
-      </p:sp>
-      <p:sp>
-        <p:nvSpPr>
-          <p:cNvPr id="208" name="Google Shape;208;p9"/>
-          <p:cNvSpPr/>
-          <p:nvPr/>
-        </p:nvSpPr>
-        <p:spPr>
-          <a:xfrm>
-            <a:off x="523875" y="5572125"/>
-            <a:ext cx="11096625" cy="619125"/>
-          </a:xfrm>
-          <a:prstGeom prst="rect">
-            <a:avLst/>
-          </a:prstGeom>
-          <a:noFill/>
-          <a:ln>
-            <a:noFill/>
-          </a:ln>
-        </p:spPr>
-        <p:txBody>
-          <a:bodyPr anchorCtr="0" anchor="t" bIns="0" lIns="0" spcFirstLastPara="1" rIns="0" wrap="square" tIns="0">
-            <a:noAutofit/>
-          </a:bodyPr>
-          <a:lstStyle/>
-          <a:p>
-            <a:pPr indent="0" lvl="0" marL="0" marR="0" rtl="0" algn="l">
-              <a:spcBef>
-                <a:spcPts val="0"/>
-              </a:spcBef>
-              <a:spcAft>
-                <a:spcPts val="0"/>
-              </a:spcAft>
-              <a:buNone/>
+            <a:pPr marL="285750" indent="-285750" lvl="0" marR="0" rtl="0" algn="l">
+              <a:spcBef>
+                <a:spcPts val="0"/>
+              </a:spcBef>
+              <a:spcAft>
+                <a:spcPts val="600"/>
+              </a:spcAft>
+              <a:buClr>
+                <a:srgbClr val="154734"/>
+              </a:buClr>
+              <a:buSzPct val="100000"/>
+              <a:buFont typeface="Arial"/>
+              <a:buChar char="•"/>
             </a:pPr>
             <a:r>
               <a:rPr b="0" lang="en-US" sz="1800">
@@ -4958,7 +4750,91 @@
                 <a:cs typeface="Calibri"/>
                 <a:sym typeface="Calibri"/>
               </a:rPr>
-              <a:t>Desktop app for Windows and macOS first. iPad version in winter 2027.</a:t>
+              <a:t>2nd to 4th year engineering, science and business</a:t>
+            </a:r>
+          </a:p>
+          <a:p>
+            <a:pPr marL="285750" indent="-285750" lvl="0" marR="0" rtl="0" algn="l">
+              <a:spcBef>
+                <a:spcPts val="0"/>
+              </a:spcBef>
+              <a:spcAft>
+                <a:spcPts val="600"/>
+              </a:spcAft>
+              <a:buClr>
+                <a:srgbClr val="154734"/>
+              </a:buClr>
+              <a:buSzPct val="100000"/>
+              <a:buFont typeface="Arial"/>
+              <a:buChar char="•"/>
+            </a:pPr>
+            <a:r>
+              <a:rPr b="0" lang="en-US" sz="1800">
+                <a:solidFill>
+                  <a:srgbClr val="1A1A1A"/>
+                </a:solidFill>
+                <a:latin typeface="Calibri"/>
+                <a:ea typeface="Calibri"/>
+                <a:cs typeface="Calibri"/>
+                <a:sym typeface="Calibri"/>
+              </a:rPr>
+              <a:t>Study from lecture slides and textbook PDFs</a:t>
+            </a:r>
+          </a:p>
+          <a:p>
+            <a:pPr marL="285750" indent="-285750" lvl="0" marR="0" rtl="0" algn="l">
+              <a:spcBef>
+                <a:spcPts val="0"/>
+              </a:spcBef>
+              <a:spcAft>
+                <a:spcPts val="600"/>
+              </a:spcAft>
+              <a:buClr>
+                <a:srgbClr val="154734"/>
+              </a:buClr>
+              <a:buSzPct val="100000"/>
+              <a:buFont typeface="Arial"/>
+              <a:buChar char="•"/>
+            </a:pPr>
+            <a:r>
+              <a:rPr b="0" lang="en-US" sz="1800">
+                <a:solidFill>
+                  <a:srgbClr val="1A1A1A"/>
+                </a:solidFill>
+                <a:latin typeface="Calibri"/>
+                <a:ea typeface="Calibri"/>
+                <a:cs typeface="Calibri"/>
+                <a:sym typeface="Calibri"/>
+              </a:rPr>
+              <a:t>Already ask ChatGPT for explanations</a:t>
+            </a:r>
+          </a:p>
+          <a:p>
+            <a:pPr marL="285750" indent="-285750" lvl="0" marR="0" rtl="0" algn="l">
+              <a:spcBef>
+                <a:spcPts val="0"/>
+              </a:spcBef>
+              <a:spcAft>
+                <a:spcPts val="600"/>
+              </a:spcAft>
+              <a:buClr>
+                <a:srgbClr val="154734"/>
+              </a:buClr>
+              <a:buSzPct val="100000"/>
+              <a:buFont typeface="Arial"/>
+              <a:buChar char="•"/>
+            </a:pPr>
+            <a:r>
+              <a:rPr b="0" lang="en-US" sz="1800">
+                <a:solidFill>
+                  <a:srgbClr val="1A1A1A"/>
+                </a:solidFill>
+                <a:latin typeface="Calibri"/>
+                <a:ea typeface="Calibri"/>
+                <a:cs typeface="Calibri"/>
+                <a:sym typeface="Calibri"/>
+              </a:rPr>
+              <a:t>Cram before midterms and finals, on a student budget</a:t>
             </a:r>
           </a:p>
         </p:txBody>
@@ -4991,7 +4867,7 @@
       <p:grpSpPr/>
       <p:sp>
         <p:nvSpPr>
-          <p:cNvPr id="214" name="Google Shape;214;p10"/>
+          <p:cNvPr id="191" name="Google Shape;191;p9"/>
           <p:cNvSpPr/>
           <p:nvPr/>
         </p:nvSpPr>
@@ -5033,14 +4909,14 @@
                 <a:cs typeface="Calibri"/>
                 <a:sym typeface="Calibri"/>
               </a:rPr>
-              <a:t>What makes it different</a:t>
-            </a:r>
-          </a:p>
-        </p:txBody>
-      </p:sp>
-      <p:sp>
-        <p:nvSpPr>
-          <p:cNvPr id="215" name="Google Shape;215;p10"/>
+              <a:t>From the page to practice, in one app</a:t>
+            </a:r>
+          </a:p>
+        </p:txBody>
+      </p:sp>
+      <p:sp>
+        <p:nvSpPr>
+          <p:cNvPr id="192" name="Google Shape;192;p9"/>
           <p:cNvSpPr/>
           <p:nvPr/>
         </p:nvSpPr>
@@ -5085,7 +4961,7 @@
       </p:sp>
       <p:sp>
         <p:nvSpPr>
-          <p:cNvPr id="216" name="Google Shape;216;p10"/>
+          <p:cNvPr id="193" name="Google Shape;193;p9"/>
           <p:cNvSpPr/>
           <p:nvPr/>
         </p:nvSpPr>
@@ -5127,14 +5003,14 @@
                 <a:cs typeface="Calibri"/>
                 <a:sym typeface="Calibri"/>
               </a:rPr>
-              <a:t>VALUE + STRATEGY</a:t>
+              <a:t>WHAT + HOW</a:t>
             </a:r>
           </a:p>
         </p:txBody>
       </p:sp>
       <p:cxnSp>
         <p:nvCxnSpPr>
-          <p:cNvPr id="217" name="Google Shape;217;p10"/>
+          <p:cNvPr id="194" name="Google Shape;194;p9"/>
           <p:cNvCxnSpPr/>
           <p:nvPr/>
         </p:nvCxnSpPr>
@@ -5160,6 +5036,2396 @@
       </p:cxnSp>
       <p:sp>
         <p:nvSpPr>
+          <p:cNvPr id="195" name="Google Shape;195;p9"/>
+          <p:cNvSpPr/>
+          <p:nvPr/>
+        </p:nvSpPr>
+        <p:spPr>
+          <a:xfrm>
+            <a:off x="11477625" y="6419850"/>
+            <a:ext cx="285750" cy="209550"/>
+          </a:xfrm>
+          <a:prstGeom prst="rect">
+            <a:avLst/>
+          </a:prstGeom>
+          <a:noFill/>
+          <a:ln>
+            <a:noFill/>
+          </a:ln>
+        </p:spPr>
+        <p:txBody>
+          <a:bodyPr anchorCtr="0" anchor="t" bIns="0" lIns="0" spcFirstLastPara="1" rIns="0" wrap="square" tIns="0">
+            <a:noAutofit/>
+          </a:bodyPr>
+          <a:lstStyle/>
+          <a:p>
+            <a:pPr indent="0" lvl="0" marL="0" marR="0" rtl="0" algn="r">
+              <a:spcBef>
+                <a:spcPts val="0"/>
+              </a:spcBef>
+              <a:spcAft>
+                <a:spcPts val="0"/>
+              </a:spcAft>
+              <a:buNone/>
+            </a:pPr>
+            <a:r>
+              <a:rPr b="0" lang="en-US" sz="1050">
+                <a:solidFill>
+                  <a:srgbClr val="65736B"/>
+                </a:solidFill>
+                <a:latin typeface="Calibri"/>
+                <a:ea typeface="Calibri"/>
+                <a:cs typeface="Calibri"/>
+                <a:sym typeface="Calibri"/>
+              </a:rPr>
+              <a:t>4</a:t>
+            </a:r>
+          </a:p>
+        </p:txBody>
+      </p:sp>
+      <p:sp>
+        <p:nvSpPr>
+          <p:cNvPr id="196" name="Google Shape;196;p9"/>
+          <p:cNvSpPr/>
+          <p:nvPr/>
+        </p:nvSpPr>
+        <p:spPr>
+          <a:xfrm>
+            <a:off x="523875" y="1323975"/>
+            <a:ext cx="9525000" cy="295275"/>
+          </a:xfrm>
+          <a:prstGeom prst="rect">
+            <a:avLst/>
+          </a:prstGeom>
+          <a:noFill/>
+          <a:ln>
+            <a:noFill/>
+          </a:ln>
+        </p:spPr>
+        <p:txBody>
+          <a:bodyPr anchorCtr="0" anchor="t" bIns="0" lIns="0" spcFirstLastPara="1" rIns="0" wrap="square" tIns="0">
+            <a:noAutofit/>
+          </a:bodyPr>
+          <a:lstStyle/>
+          <a:p>
+            <a:pPr indent="0" lvl="0" marL="0" marR="0" rtl="0" algn="l">
+              <a:spcBef>
+                <a:spcPts val="0"/>
+              </a:spcBef>
+              <a:spcAft>
+                <a:spcPts val="0"/>
+              </a:spcAft>
+              <a:buNone/>
+            </a:pPr>
+            <a:r>
+              <a:rPr b="1" lang="en-US" sz="2025">
+                <a:solidFill>
+                  <a:srgbClr val="154734"/>
+                </a:solidFill>
+                <a:latin typeface="Calibri"/>
+                <a:ea typeface="Calibri"/>
+                <a:cs typeface="Calibri"/>
+                <a:sym typeface="Calibri"/>
+              </a:rPr>
+              <a:t>How a study session works</a:t>
+            </a:r>
+          </a:p>
+        </p:txBody>
+      </p:sp>
+      <p:sp>
+        <p:nvSpPr>
+          <p:cNvPr id="197" name="Google Shape;197;p9"/>
+          <p:cNvSpPr/>
+          <p:nvPr/>
+        </p:nvSpPr>
+        <p:spPr>
+          <a:xfrm>
+            <a:off x="523875" y="1866900"/>
+            <a:ext cx="2838450" cy="1076325"/>
+          </a:xfrm>
+          <a:prstGeom prst="roundRect">
+            <a:avLst>
+              <a:gd fmla="val 8850" name="adj"/>
+            </a:avLst>
+          </a:prstGeom>
+          <a:solidFill>
+            <a:srgbClr val="EAF2EE"/>
+          </a:solidFill>
+          <a:ln cap="flat" cmpd="sng" w="13325">
+            <a:solidFill>
+              <a:srgbClr val="154734"/>
+            </a:solidFill>
+            <a:prstDash val="solid"/>
+            <a:round/>
+            <a:headEnd len="sm" w="sm" type="none"/>
+            <a:tailEnd len="sm" w="sm" type="none"/>
+          </a:ln>
+        </p:spPr>
+        <p:txBody>
+          <a:bodyPr anchorCtr="0" anchor="ctr" bIns="95250" lIns="114300" spcFirstLastPara="1" rIns="114300" wrap="square" tIns="95250">
+            <a:noAutofit/>
+          </a:bodyPr>
+          <a:lstStyle/>
+          <a:p>
+            <a:pPr indent="0" lvl="0" marL="0" marR="0" rtl="0" algn="ctr">
+              <a:spcBef>
+                <a:spcPts val="0"/>
+              </a:spcBef>
+              <a:spcAft>
+                <a:spcPts val="0"/>
+              </a:spcAft>
+              <a:buNone/>
+            </a:pPr>
+            <a:r>
+              <a:rPr b="1" lang="en-US" sz="1800">
+                <a:solidFill>
+                  <a:srgbClr val="154734"/>
+                </a:solidFill>
+                <a:latin typeface="Calibri"/>
+                <a:ea typeface="Calibri"/>
+                <a:cs typeface="Calibri"/>
+                <a:sym typeface="Calibri"/>
+              </a:rPr>
+              <a:t>Your course folders</a:t>
+            </a:r>
+          </a:p>
+          <a:p>
+            <a:pPr indent="0" lvl="0" marL="0" marR="0" rtl="0" algn="ctr">
+              <a:spcBef>
+                <a:spcPts val="0"/>
+              </a:spcBef>
+              <a:spcAft>
+                <a:spcPts val="0"/>
+              </a:spcAft>
+              <a:buNone/>
+            </a:pPr>
+            <a:r>
+              <a:rPr b="1" lang="en-US" sz="1800">
+                <a:solidFill>
+                  <a:srgbClr val="154734"/>
+                </a:solidFill>
+                <a:latin typeface="Calibri"/>
+                <a:ea typeface="Calibri"/>
+                <a:cs typeface="Calibri"/>
+                <a:sym typeface="Calibri"/>
+              </a:rPr>
+              <a:t>PDFs on your laptop</a:t>
+            </a:r>
+          </a:p>
+        </p:txBody>
+      </p:sp>
+      <p:sp>
+        <p:nvSpPr>
+          <p:cNvPr id="198" name="Google Shape;198;p9"/>
+          <p:cNvSpPr/>
+          <p:nvPr/>
+        </p:nvSpPr>
+        <p:spPr>
+          <a:xfrm>
+            <a:off x="4143375" y="1866900"/>
+            <a:ext cx="3048000" cy="1076325"/>
+          </a:xfrm>
+          <a:prstGeom prst="roundRect">
+            <a:avLst>
+              <a:gd fmla="val 8850" name="adj"/>
+            </a:avLst>
+          </a:prstGeom>
+          <a:solidFill>
+            <a:srgbClr val="FFB81C"/>
+          </a:solidFill>
+          <a:ln cap="flat" cmpd="sng" w="13325">
+            <a:solidFill>
+              <a:srgbClr val="154734"/>
+            </a:solidFill>
+            <a:prstDash val="solid"/>
+            <a:round/>
+            <a:headEnd len="sm" w="sm" type="none"/>
+            <a:tailEnd len="sm" w="sm" type="none"/>
+          </a:ln>
+        </p:spPr>
+        <p:txBody>
+          <a:bodyPr anchorCtr="0" anchor="ctr" bIns="95250" lIns="114300" spcFirstLastPara="1" rIns="114300" wrap="square" tIns="95250">
+            <a:noAutofit/>
+          </a:bodyPr>
+          <a:lstStyle/>
+          <a:p>
+            <a:pPr indent="0" lvl="0" marL="0" marR="0" rtl="0" algn="ctr">
+              <a:spcBef>
+                <a:spcPts val="0"/>
+              </a:spcBef>
+              <a:spcAft>
+                <a:spcPts val="0"/>
+              </a:spcAft>
+              <a:buNone/>
+            </a:pPr>
+            <a:r>
+              <a:rPr b="1" lang="en-US" sz="1800">
+                <a:solidFill>
+                  <a:srgbClr val="154734"/>
+                </a:solidFill>
+                <a:latin typeface="Calibri"/>
+                <a:ea typeface="Calibri"/>
+                <a:cs typeface="Calibri"/>
+                <a:sym typeface="Calibri"/>
+              </a:rPr>
+              <a:t>Open a PDF</a:t>
+            </a:r>
+          </a:p>
+          <a:p>
+            <a:pPr indent="0" lvl="0" marL="0" marR="0" rtl="0" algn="ctr">
+              <a:spcBef>
+                <a:spcPts val="0"/>
+              </a:spcBef>
+              <a:spcAft>
+                <a:spcPts val="0"/>
+              </a:spcAft>
+              <a:buNone/>
+            </a:pPr>
+            <a:r>
+              <a:rPr b="1" lang="en-US" sz="1800">
+                <a:solidFill>
+                  <a:srgbClr val="154734"/>
+                </a:solidFill>
+                <a:latin typeface="Calibri"/>
+                <a:ea typeface="Calibri"/>
+                <a:cs typeface="Calibri"/>
+                <a:sym typeface="Calibri"/>
+              </a:rPr>
+              <a:t>Select a page or passage</a:t>
+            </a:r>
+          </a:p>
+        </p:txBody>
+      </p:sp>
+      <p:sp>
+        <p:nvSpPr>
+          <p:cNvPr id="199" name="Google Shape;199;p9"/>
+          <p:cNvSpPr/>
+          <p:nvPr/>
+        </p:nvSpPr>
+        <p:spPr>
+          <a:xfrm>
+            <a:off x="7972425" y="1866900"/>
+            <a:ext cx="3695700" cy="1076325"/>
+          </a:xfrm>
+          <a:prstGeom prst="roundRect">
+            <a:avLst>
+              <a:gd fmla="val 8850" name="adj"/>
+            </a:avLst>
+          </a:prstGeom>
+          <a:solidFill>
+            <a:srgbClr val="EAF2EE"/>
+          </a:solidFill>
+          <a:ln cap="flat" cmpd="sng" w="13325">
+            <a:solidFill>
+              <a:srgbClr val="154734"/>
+            </a:solidFill>
+            <a:prstDash val="solid"/>
+            <a:round/>
+            <a:headEnd len="sm" w="sm" type="none"/>
+            <a:tailEnd len="sm" w="sm" type="none"/>
+          </a:ln>
+        </p:spPr>
+        <p:txBody>
+          <a:bodyPr anchorCtr="0" anchor="ctr" bIns="95250" lIns="114300" spcFirstLastPara="1" rIns="114300" wrap="square" tIns="95250">
+            <a:noAutofit/>
+          </a:bodyPr>
+          <a:lstStyle/>
+          <a:p>
+            <a:pPr indent="0" lvl="0" marL="0" marR="0" rtl="0" algn="ctr">
+              <a:spcBef>
+                <a:spcPts val="0"/>
+              </a:spcBef>
+              <a:spcAft>
+                <a:spcPts val="0"/>
+              </a:spcAft>
+              <a:buNone/>
+            </a:pPr>
+            <a:r>
+              <a:rPr b="1" lang="en-US" sz="1800">
+                <a:solidFill>
+                  <a:srgbClr val="154734"/>
+                </a:solidFill>
+                <a:latin typeface="Calibri"/>
+                <a:ea typeface="Calibri"/>
+                <a:cs typeface="Calibri"/>
+                <a:sym typeface="Calibri"/>
+              </a:rPr>
+              <a:t>Ask and follow up</a:t>
+            </a:r>
+          </a:p>
+          <a:p>
+            <a:pPr indent="0" lvl="0" marL="0" marR="0" rtl="0" algn="ctr">
+              <a:spcBef>
+                <a:spcPts val="0"/>
+              </a:spcBef>
+              <a:spcAft>
+                <a:spcPts val="0"/>
+              </a:spcAft>
+              <a:buNone/>
+            </a:pPr>
+            <a:r>
+              <a:rPr b="1" lang="en-US" sz="1800">
+                <a:solidFill>
+                  <a:srgbClr val="154734"/>
+                </a:solidFill>
+                <a:latin typeface="Calibri"/>
+                <a:ea typeface="Calibri"/>
+                <a:cs typeface="Calibri"/>
+                <a:sym typeface="Calibri"/>
+              </a:rPr>
+              <a:t>Answers cite the page</a:t>
+            </a:r>
+          </a:p>
+        </p:txBody>
+      </p:sp>
+      <p:cxnSp>
+        <p:nvCxnSpPr>
+          <p:cNvPr id="200" name="Google Shape;200;p9"/>
+          <p:cNvCxnSpPr>
+            <a:stCxn id="197" idx="3"/>
+            <a:endCxn id="198" idx="1"/>
+          </p:cNvCxnSpPr>
+          <p:nvPr/>
+        </p:nvCxnSpPr>
+        <p:spPr>
+          <a:xfrm>
+            <a:off x="3362325" y="2405063"/>
+            <a:ext cx="781200" cy="0"/>
+          </a:xfrm>
+          <a:prstGeom prst="straightConnector1">
+            <a:avLst/>
+          </a:prstGeom>
+          <a:noFill/>
+          <a:ln cap="flat" cmpd="sng" w="23800">
+            <a:solidFill>
+              <a:srgbClr val="154734"/>
+            </a:solidFill>
+            <a:prstDash val="solid"/>
+            <a:round/>
+            <a:headEnd len="sm" w="sm" type="none"/>
+            <a:tailEnd len="med" w="med" type="stealth"/>
+          </a:ln>
+        </p:spPr>
+      </p:cxnSp>
+      <p:cxnSp>
+        <p:nvCxnSpPr>
+          <p:cNvPr id="201" name="Google Shape;201;p9"/>
+          <p:cNvCxnSpPr>
+            <a:stCxn id="198" idx="3"/>
+            <a:endCxn id="199" idx="1"/>
+          </p:cNvCxnSpPr>
+          <p:nvPr/>
+        </p:nvCxnSpPr>
+        <p:spPr>
+          <a:xfrm>
+            <a:off x="7191375" y="2405063"/>
+            <a:ext cx="781200" cy="0"/>
+          </a:xfrm>
+          <a:prstGeom prst="straightConnector1">
+            <a:avLst/>
+          </a:prstGeom>
+          <a:noFill/>
+          <a:ln cap="flat" cmpd="sng" w="23800">
+            <a:solidFill>
+              <a:srgbClr val="154734"/>
+            </a:solidFill>
+            <a:prstDash val="solid"/>
+            <a:round/>
+            <a:headEnd len="sm" w="sm" type="none"/>
+            <a:tailEnd len="med" w="med" type="stealth"/>
+          </a:ln>
+        </p:spPr>
+      </p:cxnSp>
+      <p:sp>
+        <p:nvSpPr>
+          <p:cNvPr id="202" name="Google Shape;202;p9"/>
+          <p:cNvSpPr/>
+          <p:nvPr/>
+        </p:nvSpPr>
+        <p:spPr>
+          <a:xfrm>
+            <a:off x="7972425" y="3781425"/>
+            <a:ext cx="3695700" cy="942975"/>
+          </a:xfrm>
+          <a:prstGeom prst="roundRect">
+            <a:avLst>
+              <a:gd fmla="val 10101" name="adj"/>
+            </a:avLst>
+          </a:prstGeom>
+          <a:solidFill>
+            <a:srgbClr val="EAF2EE"/>
+          </a:solidFill>
+          <a:ln cap="flat" cmpd="sng" w="13325">
+            <a:solidFill>
+              <a:srgbClr val="154734"/>
+            </a:solidFill>
+            <a:prstDash val="solid"/>
+            <a:round/>
+            <a:headEnd len="sm" w="sm" type="none"/>
+            <a:tailEnd len="sm" w="sm" type="none"/>
+          </a:ln>
+        </p:spPr>
+        <p:txBody>
+          <a:bodyPr anchorCtr="0" anchor="ctr" bIns="95250" lIns="114300" spcFirstLastPara="1" rIns="114300" wrap="square" tIns="95250">
+            <a:noAutofit/>
+          </a:bodyPr>
+          <a:lstStyle/>
+          <a:p>
+            <a:pPr indent="0" lvl="0" marL="0" marR="0" rtl="0" algn="ctr">
+              <a:spcBef>
+                <a:spcPts val="0"/>
+              </a:spcBef>
+              <a:spcAft>
+                <a:spcPts val="0"/>
+              </a:spcAft>
+              <a:buNone/>
+            </a:pPr>
+            <a:r>
+              <a:rPr b="1" lang="en-US" sz="1800">
+                <a:solidFill>
+                  <a:srgbClr val="154734"/>
+                </a:solidFill>
+                <a:latin typeface="Calibri"/>
+                <a:ea typeface="Calibri"/>
+                <a:cs typeface="Calibri"/>
+                <a:sym typeface="Calibri"/>
+              </a:rPr>
+              <a:t>Practise</a:t>
+            </a:r>
+          </a:p>
+          <a:p>
+            <a:pPr indent="0" lvl="0" marL="0" marR="0" rtl="0" algn="ctr">
+              <a:spcBef>
+                <a:spcPts val="0"/>
+              </a:spcBef>
+              <a:spcAft>
+                <a:spcPts val="0"/>
+              </a:spcAft>
+              <a:buNone/>
+            </a:pPr>
+            <a:r>
+              <a:rPr b="1" lang="en-US" sz="1800">
+                <a:solidFill>
+                  <a:srgbClr val="154734"/>
+                </a:solidFill>
+                <a:latin typeface="Calibri"/>
+                <a:ea typeface="Calibri"/>
+                <a:cs typeface="Calibri"/>
+                <a:sym typeface="Calibri"/>
+              </a:rPr>
+              <a:t>Flashcards and a quiz</a:t>
+            </a:r>
+          </a:p>
+        </p:txBody>
+      </p:sp>
+      <p:sp>
+        <p:nvSpPr>
+          <p:cNvPr id="203" name="Google Shape;203;p9"/>
+          <p:cNvSpPr/>
+          <p:nvPr/>
+        </p:nvSpPr>
+        <p:spPr>
+          <a:xfrm>
+            <a:off x="4143375" y="3781425"/>
+            <a:ext cx="3048000" cy="942975"/>
+          </a:xfrm>
+          <a:prstGeom prst="roundRect">
+            <a:avLst>
+              <a:gd fmla="val 10101" name="adj"/>
+            </a:avLst>
+          </a:prstGeom>
+          <a:solidFill>
+            <a:srgbClr val="EAF2EE"/>
+          </a:solidFill>
+          <a:ln cap="flat" cmpd="sng" w="13325">
+            <a:solidFill>
+              <a:srgbClr val="154734"/>
+            </a:solidFill>
+            <a:prstDash val="solid"/>
+            <a:round/>
+            <a:headEnd len="sm" w="sm" type="none"/>
+            <a:tailEnd len="sm" w="sm" type="none"/>
+          </a:ln>
+        </p:spPr>
+        <p:txBody>
+          <a:bodyPr anchorCtr="0" anchor="ctr" bIns="95250" lIns="114300" spcFirstLastPara="1" rIns="114300" wrap="square" tIns="95250">
+            <a:noAutofit/>
+          </a:bodyPr>
+          <a:lstStyle/>
+          <a:p>
+            <a:pPr indent="0" lvl="0" marL="0" marR="0" rtl="0" algn="ctr">
+              <a:spcBef>
+                <a:spcPts val="0"/>
+              </a:spcBef>
+              <a:spcAft>
+                <a:spcPts val="0"/>
+              </a:spcAft>
+              <a:buNone/>
+            </a:pPr>
+            <a:r>
+              <a:rPr b="1" lang="en-US" sz="1800">
+                <a:solidFill>
+                  <a:srgbClr val="154734"/>
+                </a:solidFill>
+                <a:latin typeface="Calibri"/>
+                <a:ea typeface="Calibri"/>
+                <a:cs typeface="Calibri"/>
+                <a:sym typeface="Calibri"/>
+              </a:rPr>
+              <a:t>Plan review</a:t>
+            </a:r>
+          </a:p>
+          <a:p>
+            <a:pPr indent="0" lvl="0" marL="0" marR="0" rtl="0" algn="ctr">
+              <a:spcBef>
+                <a:spcPts val="0"/>
+              </a:spcBef>
+              <a:spcAft>
+                <a:spcPts val="0"/>
+              </a:spcAft>
+              <a:buNone/>
+            </a:pPr>
+            <a:r>
+              <a:rPr b="1" lang="en-US" sz="1800">
+                <a:solidFill>
+                  <a:srgbClr val="154734"/>
+                </a:solidFill>
+                <a:latin typeface="Calibri"/>
+                <a:ea typeface="Calibri"/>
+                <a:cs typeface="Calibri"/>
+                <a:sym typeface="Calibri"/>
+              </a:rPr>
+              <a:t>Before each exam</a:t>
+            </a:r>
+          </a:p>
+        </p:txBody>
+      </p:sp>
+      <p:cxnSp>
+        <p:nvCxnSpPr>
+          <p:cNvPr id="204" name="Google Shape;204;p9"/>
+          <p:cNvCxnSpPr>
+            <a:stCxn id="199" idx="2"/>
+            <a:endCxn id="202" idx="0"/>
+          </p:cNvCxnSpPr>
+          <p:nvPr/>
+        </p:nvCxnSpPr>
+        <p:spPr>
+          <a:xfrm>
+            <a:off x="9820275" y="2943225"/>
+            <a:ext cx="0" cy="838200"/>
+          </a:xfrm>
+          <a:prstGeom prst="straightConnector1">
+            <a:avLst/>
+          </a:prstGeom>
+          <a:noFill/>
+          <a:ln cap="flat" cmpd="sng" w="23800">
+            <a:solidFill>
+              <a:srgbClr val="154734"/>
+            </a:solidFill>
+            <a:prstDash val="solid"/>
+            <a:round/>
+            <a:headEnd len="sm" w="sm" type="none"/>
+            <a:tailEnd len="med" w="med" type="stealth"/>
+          </a:ln>
+        </p:spPr>
+      </p:cxnSp>
+      <p:cxnSp>
+        <p:nvCxnSpPr>
+          <p:cNvPr id="205" name="Google Shape;205;p9"/>
+          <p:cNvCxnSpPr>
+            <a:stCxn id="202" idx="1"/>
+            <a:endCxn id="203" idx="3"/>
+          </p:cNvCxnSpPr>
+          <p:nvPr/>
+        </p:nvCxnSpPr>
+        <p:spPr>
+          <a:xfrm rot="10800000">
+            <a:off x="7191225" y="4252913"/>
+            <a:ext cx="781200" cy="0"/>
+          </a:xfrm>
+          <a:prstGeom prst="straightConnector1">
+            <a:avLst/>
+          </a:prstGeom>
+          <a:noFill/>
+          <a:ln cap="flat" cmpd="sng" w="23800">
+            <a:solidFill>
+              <a:srgbClr val="154734"/>
+            </a:solidFill>
+            <a:prstDash val="solid"/>
+            <a:round/>
+            <a:headEnd len="sm" w="sm" type="none"/>
+            <a:tailEnd len="med" w="med" type="stealth"/>
+          </a:ln>
+        </p:spPr>
+      </p:cxnSp>
+      <p:sp>
+        <p:nvSpPr>
+          <p:cNvPr id="206" name="Google Shape;206;p9"/>
+          <p:cNvSpPr/>
+          <p:nvPr/>
+        </p:nvSpPr>
+        <p:spPr>
+          <a:xfrm>
+            <a:off x="523875" y="3609975"/>
+            <a:ext cx="2809875" cy="800100"/>
+          </a:xfrm>
+          <a:prstGeom prst="rect">
+            <a:avLst/>
+          </a:prstGeom>
+          <a:noFill/>
+          <a:ln>
+            <a:noFill/>
+          </a:ln>
+        </p:spPr>
+        <p:txBody>
+          <a:bodyPr anchorCtr="0" anchor="t" bIns="0" lIns="0" spcFirstLastPara="1" rIns="0" wrap="square" tIns="0">
+            <a:noAutofit/>
+          </a:bodyPr>
+          <a:lstStyle/>
+          <a:p>
+            <a:pPr indent="0" lvl="0" marL="0" marR="0" rtl="0" algn="l">
+              <a:spcBef>
+                <a:spcPts val="0"/>
+              </a:spcBef>
+              <a:spcAft>
+                <a:spcPts val="0"/>
+              </a:spcAft>
+              <a:buNone/>
+            </a:pPr>
+            <a:r>
+              <a:rPr b="1" lang="en-US" sz="2025">
+                <a:solidFill>
+                  <a:srgbClr val="154734"/>
+                </a:solidFill>
+                <a:latin typeface="Calibri"/>
+                <a:ea typeface="Calibri"/>
+                <a:cs typeface="Calibri"/>
+                <a:sym typeface="Calibri"/>
+              </a:rPr>
+              <a:t>You choose which</a:t>
+            </a:r>
+          </a:p>
+          <a:p>
+            <a:pPr indent="0" lvl="0" marL="0" marR="0" rtl="0" algn="l">
+              <a:spcBef>
+                <a:spcPts val="0"/>
+              </a:spcBef>
+              <a:spcAft>
+                <a:spcPts val="0"/>
+              </a:spcAft>
+              <a:buNone/>
+            </a:pPr>
+            <a:r>
+              <a:rPr b="1" lang="en-US" sz="2025">
+                <a:solidFill>
+                  <a:srgbClr val="154734"/>
+                </a:solidFill>
+                <a:latin typeface="Calibri"/>
+                <a:ea typeface="Calibri"/>
+                <a:cs typeface="Calibri"/>
+                <a:sym typeface="Calibri"/>
+              </a:rPr>
+              <a:t>folders it can see</a:t>
+            </a:r>
+          </a:p>
+        </p:txBody>
+      </p:sp>
+      <p:sp>
+        <p:nvSpPr>
+          <p:cNvPr id="207" name="Google Shape;207;p9"/>
+          <p:cNvSpPr/>
+          <p:nvPr/>
+        </p:nvSpPr>
+        <p:spPr>
+          <a:xfrm>
+            <a:off x="523875" y="5057775"/>
+            <a:ext cx="11049000" cy="361950"/>
+          </a:xfrm>
+          <a:prstGeom prst="rect">
+            <a:avLst/>
+          </a:prstGeom>
+          <a:noFill/>
+          <a:ln>
+            <a:noFill/>
+          </a:ln>
+        </p:spPr>
+        <p:txBody>
+          <a:bodyPr anchorCtr="0" anchor="t" bIns="0" lIns="0" spcFirstLastPara="1" rIns="0" wrap="square" tIns="0">
+            <a:noAutofit/>
+          </a:bodyPr>
+          <a:lstStyle/>
+          <a:p>
+            <a:pPr indent="0" lvl="0" marL="0" marR="0" rtl="0" algn="l">
+              <a:spcBef>
+                <a:spcPts val="0"/>
+              </a:spcBef>
+              <a:spcAft>
+                <a:spcPts val="0"/>
+              </a:spcAft>
+              <a:buNone/>
+            </a:pPr>
+            <a:r>
+              <a:rPr b="1" lang="en-US" sz="2100">
+                <a:solidFill>
+                  <a:srgbClr val="154734"/>
+                </a:solidFill>
+                <a:latin typeface="Calibri"/>
+                <a:ea typeface="Calibri"/>
+                <a:cs typeface="Calibri"/>
+                <a:sym typeface="Calibri"/>
+              </a:rPr>
+              <a:t>Your files stay on your laptop. Only the passage you select goes to the AI.</a:t>
+            </a:r>
+          </a:p>
+        </p:txBody>
+      </p:sp>
+      <p:sp>
+        <p:nvSpPr>
+          <p:cNvPr id="208" name="Google Shape;208;p9"/>
+          <p:cNvSpPr/>
+          <p:nvPr/>
+        </p:nvSpPr>
+        <p:spPr>
+          <a:xfrm>
+            <a:off x="523875" y="5572125"/>
+            <a:ext cx="11096625" cy="619125"/>
+          </a:xfrm>
+          <a:prstGeom prst="rect">
+            <a:avLst/>
+          </a:prstGeom>
+          <a:noFill/>
+          <a:ln>
+            <a:noFill/>
+          </a:ln>
+        </p:spPr>
+        <p:txBody>
+          <a:bodyPr anchorCtr="0" anchor="t" bIns="0" lIns="0" spcFirstLastPara="1" rIns="0" wrap="square" tIns="0">
+            <a:noAutofit/>
+          </a:bodyPr>
+          <a:lstStyle/>
+          <a:p>
+            <a:pPr indent="0" lvl="0" marL="0" marR="0" rtl="0" algn="l">
+              <a:spcBef>
+                <a:spcPts val="0"/>
+              </a:spcBef>
+              <a:spcAft>
+                <a:spcPts val="0"/>
+              </a:spcAft>
+              <a:buNone/>
+            </a:pPr>
+            <a:r>
+              <a:rPr b="0" lang="en-US" sz="1800">
+                <a:solidFill>
+                  <a:srgbClr val="1A1A1A"/>
+                </a:solidFill>
+                <a:latin typeface="Calibri"/>
+                <a:ea typeface="Calibri"/>
+                <a:cs typeface="Calibri"/>
+                <a:sym typeface="Calibri"/>
+              </a:rPr>
+              <a:t>Desktop app for Windows and macOS first. iPad version in winter 2027.</a:t>
+            </a:r>
+          </a:p>
+        </p:txBody>
+      </p:sp>
+    </p:spTree>
+  </p:cSld>
+  <p:clrMapOvr>
+    <a:masterClrMapping/>
+  </p:clrMapOvr>
+</p:sld>
+</file>
+
+<file path=ppt/slides/slide5.xml><?xml version="1.0" encoding="utf-8"?>
+<p:sld xmlns:a="http://schemas.openxmlformats.org/drawingml/2006/main" xmlns:p="http://schemas.openxmlformats.org/presentationml/2006/main" xmlns:r="http://schemas.openxmlformats.org/officeDocument/2006/relationships">
+  <p:cSld>
+    <p:bg>
+      <p:bgPr>
+        <a:solidFill>
+          <a:srgbClr val="FFFFFF"/>
+        </a:solidFill>
+        <a:effectLst/>
+      </p:bgPr>
+    </p:bg>
+    <p:spTree>
+      <p:nvGrpSpPr>
+        <p:cNvPr id="1" name=""/>
+        <p:cNvGrpSpPr/>
+        <p:nvPr/>
+      </p:nvGrpSpPr>
+      <p:grpSpPr/>
+      <p:sp>
+        <p:nvSpPr>
+          <p:cNvPr id="191" name="Google Shape;191;p9"/>
+          <p:cNvSpPr/>
+          <p:nvPr/>
+        </p:nvSpPr>
+        <p:spPr>
+          <a:xfrm>
+            <a:off x="514350" y="428625"/>
+            <a:ext cx="8477250" cy="628650"/>
+          </a:xfrm>
+          <a:prstGeom prst="rect">
+            <a:avLst/>
+          </a:prstGeom>
+          <a:noFill/>
+          <a:ln>
+            <a:noFill/>
+          </a:ln>
+        </p:spPr>
+        <p:txBody>
+          <a:bodyPr anchorCtr="0" anchor="t" bIns="0" lIns="0" spcFirstLastPara="1" rIns="0" wrap="square" tIns="0">
+            <a:noAutofit/>
+          </a:bodyPr>
+          <a:lstStyle/>
+          <a:p>
+            <a:pPr indent="0" lvl="0" marL="0" marR="0" rtl="0" algn="l">
+              <a:spcBef>
+                <a:spcPts val="0"/>
+              </a:spcBef>
+              <a:spcAft>
+                <a:spcPts val="0"/>
+              </a:spcAft>
+              <a:buNone/>
+            </a:pPr>
+            <a:r>
+              <a:rPr b="1" lang="en-US" sz="3000">
+                <a:solidFill>
+                  <a:srgbClr val="154734"/>
+                </a:solidFill>
+                <a:latin typeface="Calibri"/>
+                <a:ea typeface="Calibri"/>
+                <a:cs typeface="Calibri"/>
+                <a:sym typeface="Calibri"/>
+              </a:rPr>
+              <a:t>A tutor you can keep asking until it clicks</a:t>
+            </a:r>
+          </a:p>
+        </p:txBody>
+      </p:sp>
+      <p:sp>
+        <p:nvSpPr>
+          <p:cNvPr id="192" name="Google Shape;192;p9"/>
+          <p:cNvSpPr/>
+          <p:nvPr/>
+        </p:nvSpPr>
+        <p:spPr>
+          <a:xfrm>
+            <a:off x="9286875" y="409575"/>
+            <a:ext cx="2381250" cy="361950"/>
+          </a:xfrm>
+          <a:prstGeom prst="roundRect">
+            <a:avLst>
+              <a:gd fmla="val 39474" name="adj"/>
+            </a:avLst>
+          </a:prstGeom>
+          <a:solidFill>
+            <a:srgbClr val="FFB81C"/>
+          </a:solidFill>
+          <a:ln>
+            <a:noFill/>
+          </a:ln>
+        </p:spPr>
+        <p:txBody>
+          <a:bodyPr anchorCtr="0" anchor="ctr" bIns="91425" lIns="91425" spcFirstLastPara="1" rIns="91425" wrap="square" tIns="91425">
+            <a:noAutofit/>
+          </a:bodyPr>
+          <a:lstStyle/>
+          <a:p>
+            <a:pPr indent="0" lvl="0" marL="0" rtl="0" algn="l">
+              <a:spcBef>
+                <a:spcPts val="0"/>
+              </a:spcBef>
+              <a:spcAft>
+                <a:spcPts val="0"/>
+              </a:spcAft>
+              <a:buNone/>
+            </a:pPr>
+            <a:r>
+              <a:t/>
+            </a:r>
+            <a:endParaRPr/>
+          </a:p>
+        </p:txBody>
+      </p:sp>
+      <p:sp>
+        <p:nvSpPr>
+          <p:cNvPr id="193" name="Google Shape;193;p9"/>
+          <p:cNvSpPr/>
+          <p:nvPr/>
+        </p:nvSpPr>
+        <p:spPr>
+          <a:xfrm>
+            <a:off x="9382125" y="485775"/>
+            <a:ext cx="2190750" cy="219075"/>
+          </a:xfrm>
+          <a:prstGeom prst="rect">
+            <a:avLst/>
+          </a:prstGeom>
+          <a:noFill/>
+          <a:ln>
+            <a:noFill/>
+          </a:ln>
+        </p:spPr>
+        <p:txBody>
+          <a:bodyPr anchorCtr="0" anchor="t" bIns="0" lIns="0" spcFirstLastPara="1" rIns="0" wrap="square" tIns="0">
+            <a:noAutofit/>
+          </a:bodyPr>
+          <a:lstStyle/>
+          <a:p>
+            <a:pPr indent="0" lvl="0" marL="0" marR="0" rtl="0" algn="ctr">
+              <a:spcBef>
+                <a:spcPts val="0"/>
+              </a:spcBef>
+              <a:spcAft>
+                <a:spcPts val="0"/>
+              </a:spcAft>
+              <a:buNone/>
+            </a:pPr>
+            <a:r>
+              <a:rPr b="1" lang="en-US" sz="1200">
+                <a:solidFill>
+                  <a:srgbClr val="154734"/>
+                </a:solidFill>
+                <a:latin typeface="Calibri"/>
+                <a:ea typeface="Calibri"/>
+                <a:cs typeface="Calibri"/>
+                <a:sym typeface="Calibri"/>
+              </a:rPr>
+              <a:t>HOW</a:t>
+            </a:r>
+          </a:p>
+        </p:txBody>
+      </p:sp>
+      <p:cxnSp>
+        <p:nvCxnSpPr>
+          <p:cNvPr id="194" name="Google Shape;194;p9"/>
+          <p:cNvCxnSpPr/>
+          <p:nvPr/>
+        </p:nvCxnSpPr>
+        <p:spPr>
+          <a:xfrm>
+            <a:off x="0" y="6819900"/>
+            <a:ext cx="12191695" cy="0"/>
+          </a:xfrm>
+          <a:prstGeom prst="straightConnector1">
+            <a:avLst/>
+          </a:prstGeom>
+          <a:noFill/>
+          <a:ln cap="flat" cmpd="sng" w="47625">
+            <a:solidFill>
+              <a:srgbClr val="FFB81C"/>
+            </a:solidFill>
+            <a:prstDash val="solid"/>
+            <a:round/>
+            <a:headEnd len="sm" w="sm" type="none"/>
+            <a:tailEnd len="sm" w="sm" type="none"/>
+          </a:ln>
+        </p:spPr>
+      </p:cxnSp>
+      <p:sp>
+        <p:nvSpPr>
+          <p:cNvPr id="195" name="Google Shape;195;p9"/>
+          <p:cNvSpPr/>
+          <p:nvPr/>
+        </p:nvSpPr>
+        <p:spPr>
+          <a:xfrm>
+            <a:off x="11477625" y="6419850"/>
+            <a:ext cx="285750" cy="209550"/>
+          </a:xfrm>
+          <a:prstGeom prst="rect">
+            <a:avLst/>
+          </a:prstGeom>
+          <a:noFill/>
+          <a:ln>
+            <a:noFill/>
+          </a:ln>
+        </p:spPr>
+        <p:txBody>
+          <a:bodyPr anchorCtr="0" anchor="t" bIns="0" lIns="0" spcFirstLastPara="1" rIns="0" wrap="square" tIns="0">
+            <a:noAutofit/>
+          </a:bodyPr>
+          <a:lstStyle/>
+          <a:p>
+            <a:pPr indent="0" lvl="0" marL="0" marR="0" rtl="0" algn="r">
+              <a:spcBef>
+                <a:spcPts val="0"/>
+              </a:spcBef>
+              <a:spcAft>
+                <a:spcPts val="0"/>
+              </a:spcAft>
+              <a:buNone/>
+            </a:pPr>
+            <a:r>
+              <a:rPr b="0" lang="en-US" sz="1050">
+                <a:solidFill>
+                  <a:srgbClr val="65736B"/>
+                </a:solidFill>
+                <a:latin typeface="Calibri"/>
+                <a:ea typeface="Calibri"/>
+                <a:cs typeface="Calibri"/>
+                <a:sym typeface="Calibri"/>
+              </a:rPr>
+              <a:t>5</a:t>
+            </a:r>
+          </a:p>
+        </p:txBody>
+      </p:sp>
+      <p:sp>
+        <p:nvSpPr>
+          <p:cNvPr id="196" name="Google Shape;196;p9"/>
+          <p:cNvSpPr/>
+          <p:nvPr/>
+        </p:nvSpPr>
+        <p:spPr>
+          <a:xfrm>
+            <a:off x="523875" y="1323975"/>
+            <a:ext cx="9525000" cy="295275"/>
+          </a:xfrm>
+          <a:prstGeom prst="rect">
+            <a:avLst/>
+          </a:prstGeom>
+          <a:noFill/>
+          <a:ln>
+            <a:noFill/>
+          </a:ln>
+        </p:spPr>
+        <p:txBody>
+          <a:bodyPr anchorCtr="0" anchor="t" bIns="0" lIns="0" spcFirstLastPara="1" rIns="0" wrap="square" tIns="0">
+            <a:noAutofit/>
+          </a:bodyPr>
+          <a:lstStyle/>
+          <a:p>
+            <a:pPr indent="0" lvl="0" marL="0" marR="0" rtl="0" algn="l">
+              <a:spcBef>
+                <a:spcPts val="0"/>
+              </a:spcBef>
+              <a:spcAft>
+                <a:spcPts val="0"/>
+              </a:spcAft>
+              <a:buNone/>
+            </a:pPr>
+            <a:r>
+              <a:rPr b="1" lang="en-US" sz="2025">
+                <a:solidFill>
+                  <a:srgbClr val="154734"/>
+                </a:solidFill>
+                <a:latin typeface="Calibri"/>
+                <a:ea typeface="Calibri"/>
+                <a:cs typeface="Calibri"/>
+                <a:sym typeface="Calibri"/>
+              </a:rPr>
+              <a:t>Example conversation</a:t>
+            </a:r>
+          </a:p>
+        </p:txBody>
+      </p:sp>
+      <p:sp>
+        <p:nvSpPr>
+          <p:cNvPr id="197" name="Chat bubble 197"/>
+          <p:cNvSpPr/>
+          <p:nvPr/>
+        </p:nvSpPr>
+        <p:spPr>
+          <a:xfrm>
+            <a:off x="3108960" y="1783080"/>
+            <a:ext cx="3566160" cy="457200"/>
+          </a:xfrm>
+          <a:prstGeom prst="roundRect">
+            <a:avLst>
+              <a:gd fmla="val 16000" name="adj"/>
+            </a:avLst>
+          </a:prstGeom>
+          <a:solidFill>
+            <a:srgbClr val="FFB81C"/>
+          </a:solidFill>
+          <a:ln cap="flat" cmpd="sng" w="13325">
+            <a:solidFill>
+              <a:srgbClr val="154734"/>
+            </a:solidFill>
+            <a:prstDash val="solid"/>
+            <a:round/>
+            <a:headEnd len="sm" w="sm" type="none"/>
+            <a:tailEnd len="sm" w="sm" type="none"/>
+          </a:ln>
+        </p:spPr>
+      </p:sp>
+      <p:sp>
+        <p:nvSpPr>
+          <p:cNvPr id="198" name="Text 198"/>
+          <p:cNvSpPr txBox="1"/>
+          <p:nvPr/>
+        </p:nvSpPr>
+        <p:spPr>
+          <a:xfrm>
+            <a:off x="3273552" y="1783080"/>
+            <a:ext cx="3236976" cy="457200"/>
+          </a:xfrm>
+          <a:prstGeom prst="rect">
+            <a:avLst/>
+          </a:prstGeom>
+          <a:noFill/>
+          <a:ln>
+            <a:noFill/>
+          </a:ln>
+        </p:spPr>
+        <p:txBody>
+          <a:bodyPr anchorCtr="0" anchor="ctr" bIns="0" lIns="0" spcFirstLastPara="1" rIns="0" wrap="square" tIns="0">
+            <a:noAutofit/>
+          </a:bodyPr>
+          <a:lstStyle/>
+          <a:p>
+            <a:pPr marL="0" indent="0" lvl="0" marR="0" rtl="0" algn="l">
+              <a:spcBef>
+                <a:spcPts val="0"/>
+              </a:spcBef>
+              <a:spcAft>
+                <a:spcPts val="0"/>
+              </a:spcAft>
+              <a:buNone/>
+            </a:pPr>
+            <a:r>
+              <a:rPr b="1" lang="en-US" sz="1575">
+                <a:solidFill>
+                  <a:srgbClr val="154734"/>
+                </a:solidFill>
+                <a:latin typeface="Calibri"/>
+                <a:ea typeface="Calibri"/>
+                <a:cs typeface="Calibri"/>
+                <a:sym typeface="Calibri"/>
+              </a:rPr>
+              <a:t>Why does the current split here?</a:t>
+            </a:r>
+          </a:p>
+        </p:txBody>
+      </p:sp>
+      <p:sp>
+        <p:nvSpPr>
+          <p:cNvPr id="199" name="Chat bubble 199"/>
+          <p:cNvSpPr/>
+          <p:nvPr/>
+        </p:nvSpPr>
+        <p:spPr>
+          <a:xfrm>
+            <a:off x="523951" y="2331720"/>
+            <a:ext cx="5120640" cy="777240"/>
+          </a:xfrm>
+          <a:prstGeom prst="roundRect">
+            <a:avLst>
+              <a:gd fmla="val 16000" name="adj"/>
+            </a:avLst>
+          </a:prstGeom>
+          <a:solidFill>
+            <a:srgbClr val="EAF2EE"/>
+          </a:solidFill>
+          <a:ln cap="flat" cmpd="sng" w="13325">
+            <a:solidFill>
+              <a:srgbClr val="154734"/>
+            </a:solidFill>
+            <a:prstDash val="solid"/>
+            <a:round/>
+            <a:headEnd len="sm" w="sm" type="none"/>
+            <a:tailEnd len="sm" w="sm" type="none"/>
+          </a:ln>
+        </p:spPr>
+      </p:sp>
+      <p:sp>
+        <p:nvSpPr>
+          <p:cNvPr id="200" name="Text 200"/>
+          <p:cNvSpPr txBox="1"/>
+          <p:nvPr/>
+        </p:nvSpPr>
+        <p:spPr>
+          <a:xfrm>
+            <a:off x="688543" y="2331720"/>
+            <a:ext cx="4791456" cy="777240"/>
+          </a:xfrm>
+          <a:prstGeom prst="rect">
+            <a:avLst/>
+          </a:prstGeom>
+          <a:noFill/>
+          <a:ln>
+            <a:noFill/>
+          </a:ln>
+        </p:spPr>
+        <p:txBody>
+          <a:bodyPr anchorCtr="0" anchor="ctr" bIns="0" lIns="0" spcFirstLastPara="1" rIns="0" wrap="square" tIns="0">
+            <a:noAutofit/>
+          </a:bodyPr>
+          <a:lstStyle/>
+          <a:p>
+            <a:pPr marL="0" indent="0" lvl="0" marR="0" rtl="0" algn="l">
+              <a:spcBef>
+                <a:spcPts val="0"/>
+              </a:spcBef>
+              <a:spcAft>
+                <a:spcPts val="0"/>
+              </a:spcAft>
+              <a:buNone/>
+            </a:pPr>
+            <a:r>
+              <a:rPr b="0" lang="en-US" sz="1575">
+                <a:solidFill>
+                  <a:srgbClr val="1A1A1A"/>
+                </a:solidFill>
+                <a:latin typeface="Calibri"/>
+                <a:ea typeface="Calibri"/>
+                <a:cs typeface="Calibri"/>
+                <a:sym typeface="Calibri"/>
+              </a:rPr>
+              <a:t>Each parallel path gets the full voltage, so the current divides between them.</a:t>
+            </a:r>
+          </a:p>
+          <a:p>
+            <a:pPr marL="0" indent="0" lvl="0" marR="0" rtl="0" algn="l">
+              <a:spcBef>
+                <a:spcPts val="0"/>
+              </a:spcBef>
+              <a:spcAft>
+                <a:spcPts val="0"/>
+              </a:spcAft>
+              <a:buNone/>
+            </a:pPr>
+            <a:r>
+              <a:rPr b="1" lang="en-US" sz="1200">
+                <a:solidFill>
+                  <a:srgbClr val="154734"/>
+                </a:solidFill>
+                <a:latin typeface="Calibri"/>
+                <a:ea typeface="Calibri"/>
+                <a:cs typeface="Calibri"/>
+                <a:sym typeface="Calibri"/>
+              </a:rPr>
+              <a:t>Lecture 6, p. 14</a:t>
+            </a:r>
+          </a:p>
+        </p:txBody>
+      </p:sp>
+      <p:sp>
+        <p:nvSpPr>
+          <p:cNvPr id="201" name="Chat bubble 201"/>
+          <p:cNvSpPr/>
+          <p:nvPr/>
+        </p:nvSpPr>
+        <p:spPr>
+          <a:xfrm>
+            <a:off x="3108960" y="3200400"/>
+            <a:ext cx="3566160" cy="457200"/>
+          </a:xfrm>
+          <a:prstGeom prst="roundRect">
+            <a:avLst>
+              <a:gd fmla="val 16000" name="adj"/>
+            </a:avLst>
+          </a:prstGeom>
+          <a:solidFill>
+            <a:srgbClr val="FFB81C"/>
+          </a:solidFill>
+          <a:ln cap="flat" cmpd="sng" w="13325">
+            <a:solidFill>
+              <a:srgbClr val="154734"/>
+            </a:solidFill>
+            <a:prstDash val="solid"/>
+            <a:round/>
+            <a:headEnd len="sm" w="sm" type="none"/>
+            <a:tailEnd len="sm" w="sm" type="none"/>
+          </a:ln>
+        </p:spPr>
+      </p:sp>
+      <p:sp>
+        <p:nvSpPr>
+          <p:cNvPr id="202" name="Text 202"/>
+          <p:cNvSpPr txBox="1"/>
+          <p:nvPr/>
+        </p:nvSpPr>
+        <p:spPr>
+          <a:xfrm>
+            <a:off x="3273552" y="3200400"/>
+            <a:ext cx="3236976" cy="457200"/>
+          </a:xfrm>
+          <a:prstGeom prst="rect">
+            <a:avLst/>
+          </a:prstGeom>
+          <a:noFill/>
+          <a:ln>
+            <a:noFill/>
+          </a:ln>
+        </p:spPr>
+        <p:txBody>
+          <a:bodyPr anchorCtr="0" anchor="ctr" bIns="0" lIns="0" spcFirstLastPara="1" rIns="0" wrap="square" tIns="0">
+            <a:noAutofit/>
+          </a:bodyPr>
+          <a:lstStyle/>
+          <a:p>
+            <a:pPr marL="0" indent="0" lvl="0" marR="0" rtl="0" algn="l">
+              <a:spcBef>
+                <a:spcPts val="0"/>
+              </a:spcBef>
+              <a:spcAft>
+                <a:spcPts val="0"/>
+              </a:spcAft>
+              <a:buNone/>
+            </a:pPr>
+            <a:r>
+              <a:rPr b="1" lang="en-US" sz="1575">
+                <a:solidFill>
+                  <a:srgbClr val="154734"/>
+                </a:solidFill>
+                <a:latin typeface="Calibri"/>
+                <a:ea typeface="Calibri"/>
+                <a:cs typeface="Calibri"/>
+                <a:sym typeface="Calibri"/>
+              </a:rPr>
+              <a:t>Still lost. Can you use numbers?</a:t>
+            </a:r>
+          </a:p>
+        </p:txBody>
+      </p:sp>
+      <p:sp>
+        <p:nvSpPr>
+          <p:cNvPr id="203" name="Chat bubble 203"/>
+          <p:cNvSpPr/>
+          <p:nvPr/>
+        </p:nvSpPr>
+        <p:spPr>
+          <a:xfrm>
+            <a:off x="523951" y="3749040"/>
+            <a:ext cx="5120640" cy="914400"/>
+          </a:xfrm>
+          <a:prstGeom prst="roundRect">
+            <a:avLst>
+              <a:gd fmla="val 16000" name="adj"/>
+            </a:avLst>
+          </a:prstGeom>
+          <a:solidFill>
+            <a:srgbClr val="EAF2EE"/>
+          </a:solidFill>
+          <a:ln cap="flat" cmpd="sng" w="13325">
+            <a:solidFill>
+              <a:srgbClr val="154734"/>
+            </a:solidFill>
+            <a:prstDash val="solid"/>
+            <a:round/>
+            <a:headEnd len="sm" w="sm" type="none"/>
+            <a:tailEnd len="sm" w="sm" type="none"/>
+          </a:ln>
+        </p:spPr>
+      </p:sp>
+      <p:sp>
+        <p:nvSpPr>
+          <p:cNvPr id="204" name="Text 204"/>
+          <p:cNvSpPr txBox="1"/>
+          <p:nvPr/>
+        </p:nvSpPr>
+        <p:spPr>
+          <a:xfrm>
+            <a:off x="688543" y="3749040"/>
+            <a:ext cx="4791456" cy="914400"/>
+          </a:xfrm>
+          <a:prstGeom prst="rect">
+            <a:avLst/>
+          </a:prstGeom>
+          <a:noFill/>
+          <a:ln>
+            <a:noFill/>
+          </a:ln>
+        </p:spPr>
+        <p:txBody>
+          <a:bodyPr anchorCtr="0" anchor="ctr" bIns="0" lIns="0" spcFirstLastPara="1" rIns="0" wrap="square" tIns="0">
+            <a:noAutofit/>
+          </a:bodyPr>
+          <a:lstStyle/>
+          <a:p>
+            <a:pPr marL="0" indent="0" lvl="0" marR="0" rtl="0" algn="l">
+              <a:spcBef>
+                <a:spcPts val="0"/>
+              </a:spcBef>
+              <a:spcAft>
+                <a:spcPts val="0"/>
+              </a:spcAft>
+              <a:buNone/>
+            </a:pPr>
+            <a:r>
+              <a:rPr b="0" lang="en-US" sz="1575">
+                <a:solidFill>
+                  <a:srgbClr val="1A1A1A"/>
+                </a:solidFill>
+                <a:latin typeface="Calibri"/>
+                <a:ea typeface="Calibri"/>
+                <a:cs typeface="Calibri"/>
+                <a:sym typeface="Calibri"/>
+              </a:rPr>
+              <a:t>12 V across two 6 Ω resistors: 2 A each, 4 A total. Quick check: remove one. What’s the total now?</a:t>
+            </a:r>
+          </a:p>
+          <a:p>
+            <a:pPr marL="0" indent="0" lvl="0" marR="0" rtl="0" algn="l">
+              <a:spcBef>
+                <a:spcPts val="0"/>
+              </a:spcBef>
+              <a:spcAft>
+                <a:spcPts val="0"/>
+              </a:spcAft>
+              <a:buNone/>
+            </a:pPr>
+            <a:r>
+              <a:rPr b="1" lang="en-US" sz="1200">
+                <a:solidFill>
+                  <a:srgbClr val="154734"/>
+                </a:solidFill>
+                <a:latin typeface="Calibri"/>
+                <a:ea typeface="Calibri"/>
+                <a:cs typeface="Calibri"/>
+                <a:sym typeface="Calibri"/>
+              </a:rPr>
+              <a:t>Lecture 6, p. 14</a:t>
+            </a:r>
+          </a:p>
+        </p:txBody>
+      </p:sp>
+      <p:sp>
+        <p:nvSpPr>
+          <p:cNvPr id="205" name="Chat bubble 205"/>
+          <p:cNvSpPr/>
+          <p:nvPr/>
+        </p:nvSpPr>
+        <p:spPr>
+          <a:xfrm>
+            <a:off x="4297680" y="4754880"/>
+            <a:ext cx="2377440" cy="457200"/>
+          </a:xfrm>
+          <a:prstGeom prst="roundRect">
+            <a:avLst>
+              <a:gd fmla="val 16000" name="adj"/>
+            </a:avLst>
+          </a:prstGeom>
+          <a:solidFill>
+            <a:srgbClr val="FFB81C"/>
+          </a:solidFill>
+          <a:ln cap="flat" cmpd="sng" w="13325">
+            <a:solidFill>
+              <a:srgbClr val="154734"/>
+            </a:solidFill>
+            <a:prstDash val="solid"/>
+            <a:round/>
+            <a:headEnd len="sm" w="sm" type="none"/>
+            <a:tailEnd len="sm" w="sm" type="none"/>
+          </a:ln>
+        </p:spPr>
+      </p:sp>
+      <p:sp>
+        <p:nvSpPr>
+          <p:cNvPr id="206" name="Text 206"/>
+          <p:cNvSpPr txBox="1"/>
+          <p:nvPr/>
+        </p:nvSpPr>
+        <p:spPr>
+          <a:xfrm>
+            <a:off x="4462272" y="4754880"/>
+            <a:ext cx="2048256" cy="457200"/>
+          </a:xfrm>
+          <a:prstGeom prst="rect">
+            <a:avLst/>
+          </a:prstGeom>
+          <a:noFill/>
+          <a:ln>
+            <a:noFill/>
+          </a:ln>
+        </p:spPr>
+        <p:txBody>
+          <a:bodyPr anchorCtr="0" anchor="ctr" bIns="0" lIns="0" spcFirstLastPara="1" rIns="0" wrap="square" tIns="0">
+            <a:noAutofit/>
+          </a:bodyPr>
+          <a:lstStyle/>
+          <a:p>
+            <a:pPr marL="0" indent="0" lvl="0" marR="0" rtl="0" algn="l">
+              <a:spcBef>
+                <a:spcPts val="0"/>
+              </a:spcBef>
+              <a:spcAft>
+                <a:spcPts val="0"/>
+              </a:spcAft>
+              <a:buNone/>
+            </a:pPr>
+            <a:r>
+              <a:rPr b="1" lang="en-US" sz="1575">
+                <a:solidFill>
+                  <a:srgbClr val="154734"/>
+                </a:solidFill>
+                <a:latin typeface="Calibri"/>
+                <a:ea typeface="Calibri"/>
+                <a:cs typeface="Calibri"/>
+                <a:sym typeface="Calibri"/>
+              </a:rPr>
+              <a:t>2 A, so it halves?</a:t>
+            </a:r>
+          </a:p>
+        </p:txBody>
+      </p:sp>
+      <p:sp>
+        <p:nvSpPr>
+          <p:cNvPr id="207" name="Chat bubble 207"/>
+          <p:cNvSpPr/>
+          <p:nvPr/>
+        </p:nvSpPr>
+        <p:spPr>
+          <a:xfrm>
+            <a:off x="523951" y="5303520"/>
+            <a:ext cx="3840480" cy="457200"/>
+          </a:xfrm>
+          <a:prstGeom prst="roundRect">
+            <a:avLst>
+              <a:gd fmla="val 16000" name="adj"/>
+            </a:avLst>
+          </a:prstGeom>
+          <a:solidFill>
+            <a:srgbClr val="EAF2EE"/>
+          </a:solidFill>
+          <a:ln cap="flat" cmpd="sng" w="13325">
+            <a:solidFill>
+              <a:srgbClr val="154734"/>
+            </a:solidFill>
+            <a:prstDash val="solid"/>
+            <a:round/>
+            <a:headEnd len="sm" w="sm" type="none"/>
+            <a:tailEnd len="sm" w="sm" type="none"/>
+          </a:ln>
+        </p:spPr>
+      </p:sp>
+      <p:sp>
+        <p:nvSpPr>
+          <p:cNvPr id="208" name="Text 208"/>
+          <p:cNvSpPr txBox="1"/>
+          <p:nvPr/>
+        </p:nvSpPr>
+        <p:spPr>
+          <a:xfrm>
+            <a:off x="688543" y="5303520"/>
+            <a:ext cx="3511296" cy="457200"/>
+          </a:xfrm>
+          <a:prstGeom prst="rect">
+            <a:avLst/>
+          </a:prstGeom>
+          <a:noFill/>
+          <a:ln>
+            <a:noFill/>
+          </a:ln>
+        </p:spPr>
+        <p:txBody>
+          <a:bodyPr anchorCtr="0" anchor="ctr" bIns="0" lIns="0" spcFirstLastPara="1" rIns="0" wrap="square" tIns="0">
+            <a:noAutofit/>
+          </a:bodyPr>
+          <a:lstStyle/>
+          <a:p>
+            <a:pPr marL="0" indent="0" lvl="0" marR="0" rtl="0" algn="l">
+              <a:spcBef>
+                <a:spcPts val="0"/>
+              </a:spcBef>
+              <a:spcAft>
+                <a:spcPts val="0"/>
+              </a:spcAft>
+              <a:buNone/>
+            </a:pPr>
+            <a:r>
+              <a:rPr b="0" lang="en-US" sz="1575">
+                <a:solidFill>
+                  <a:srgbClr val="1A1A1A"/>
+                </a:solidFill>
+                <a:latin typeface="Calibri"/>
+                <a:ea typeface="Calibri"/>
+                <a:cs typeface="Calibri"/>
+                <a:sym typeface="Calibri"/>
+              </a:rPr>
+              <a:t>Exactly. Want flashcards on this page?</a:t>
+            </a:r>
+          </a:p>
+        </p:txBody>
+      </p:sp>
+      <p:sp>
+        <p:nvSpPr>
+          <p:cNvPr id="209" name="Text 209"/>
+          <p:cNvSpPr txBox="1"/>
+          <p:nvPr/>
+        </p:nvSpPr>
+        <p:spPr>
+          <a:xfrm>
+            <a:off x="7178040" y="1316736"/>
+            <a:ext cx="548640" cy="457200"/>
+          </a:xfrm>
+          <a:prstGeom prst="rect">
+            <a:avLst/>
+          </a:prstGeom>
+          <a:noFill/>
+          <a:ln>
+            <a:noFill/>
+          </a:ln>
+        </p:spPr>
+        <p:txBody>
+          <a:bodyPr anchorCtr="0" anchor="t" bIns="0" lIns="0" spcFirstLastPara="1" rIns="0" wrap="square" tIns="0">
+            <a:noAutofit/>
+          </a:bodyPr>
+          <a:lstStyle/>
+          <a:p>
+            <a:pPr marL="0" indent="0" lvl="0" marR="0" rtl="0" algn="l">
+              <a:spcBef>
+                <a:spcPts val="0"/>
+              </a:spcBef>
+              <a:spcAft>
+                <a:spcPts val="0"/>
+              </a:spcAft>
+              <a:buNone/>
+            </a:pPr>
+            <a:r>
+              <a:rPr b="1" lang="en-US" sz="2400">
+                <a:solidFill>
+                  <a:srgbClr val="FFB81C"/>
+                </a:solidFill>
+                <a:latin typeface="Calibri"/>
+                <a:ea typeface="Calibri"/>
+                <a:cs typeface="Calibri"/>
+                <a:sym typeface="Calibri"/>
+              </a:rPr>
+              <a:t>01</a:t>
+            </a:r>
+          </a:p>
+        </p:txBody>
+      </p:sp>
+      <p:sp>
+        <p:nvSpPr>
+          <p:cNvPr id="210" name="Text 210"/>
+          <p:cNvSpPr txBox="1"/>
+          <p:nvPr/>
+        </p:nvSpPr>
+        <p:spPr>
+          <a:xfrm>
+            <a:off x="7772400" y="1371600"/>
+            <a:ext cx="3895344" cy="292608"/>
+          </a:xfrm>
+          <a:prstGeom prst="rect">
+            <a:avLst/>
+          </a:prstGeom>
+          <a:noFill/>
+          <a:ln>
+            <a:noFill/>
+          </a:ln>
+        </p:spPr>
+        <p:txBody>
+          <a:bodyPr anchorCtr="0" anchor="t" bIns="0" lIns="0" spcFirstLastPara="1" rIns="0" wrap="square" tIns="0">
+            <a:noAutofit/>
+          </a:bodyPr>
+          <a:lstStyle/>
+          <a:p>
+            <a:pPr marL="0" indent="0" lvl="0" marR="0" rtl="0" algn="l">
+              <a:spcBef>
+                <a:spcPts val="0"/>
+              </a:spcBef>
+              <a:spcAft>
+                <a:spcPts val="0"/>
+              </a:spcAft>
+              <a:buNone/>
+            </a:pPr>
+            <a:r>
+              <a:rPr b="1" lang="en-US" sz="1650">
+                <a:solidFill>
+                  <a:srgbClr val="154734"/>
+                </a:solidFill>
+                <a:latin typeface="Calibri"/>
+                <a:ea typeface="Calibri"/>
+                <a:cs typeface="Calibri"/>
+                <a:sym typeface="Calibri"/>
+              </a:rPr>
+              <a:t>Ask in your own words</a:t>
+            </a:r>
+          </a:p>
+        </p:txBody>
+      </p:sp>
+      <p:sp>
+        <p:nvSpPr>
+          <p:cNvPr id="211" name="Text 211"/>
+          <p:cNvSpPr txBox="1"/>
+          <p:nvPr/>
+        </p:nvSpPr>
+        <p:spPr>
+          <a:xfrm>
+            <a:off x="7772400" y="1719072"/>
+            <a:ext cx="3895344" cy="640080"/>
+          </a:xfrm>
+          <a:prstGeom prst="rect">
+            <a:avLst/>
+          </a:prstGeom>
+          <a:noFill/>
+          <a:ln>
+            <a:noFill/>
+          </a:ln>
+        </p:spPr>
+        <p:txBody>
+          <a:bodyPr anchorCtr="0" anchor="t" bIns="0" lIns="0" spcFirstLastPara="1" rIns="0" wrap="square" tIns="0">
+            <a:noAutofit/>
+          </a:bodyPr>
+          <a:lstStyle/>
+          <a:p>
+            <a:pPr marL="0" indent="0" lvl="0" marR="0" rtl="0" algn="l">
+              <a:spcBef>
+                <a:spcPts val="0"/>
+              </a:spcBef>
+              <a:spcAft>
+                <a:spcPts val="0"/>
+              </a:spcAft>
+              <a:buNone/>
+            </a:pPr>
+            <a:r>
+              <a:rPr b="0" lang="en-US" sz="1575">
+                <a:solidFill>
+                  <a:srgbClr val="1A1A1A"/>
+                </a:solidFill>
+                <a:latin typeface="Calibri"/>
+                <a:ea typeface="Calibri"/>
+                <a:cs typeface="Calibri"/>
+                <a:sym typeface="Calibri"/>
+              </a:rPr>
+              <a:t>Type a question about the passage you selected.</a:t>
+            </a:r>
+          </a:p>
+        </p:txBody>
+      </p:sp>
+      <p:sp>
+        <p:nvSpPr>
+          <p:cNvPr id="212" name="Text 212"/>
+          <p:cNvSpPr txBox="1"/>
+          <p:nvPr/>
+        </p:nvSpPr>
+        <p:spPr>
+          <a:xfrm>
+            <a:off x="7178040" y="2414016"/>
+            <a:ext cx="548640" cy="457200"/>
+          </a:xfrm>
+          <a:prstGeom prst="rect">
+            <a:avLst/>
+          </a:prstGeom>
+          <a:noFill/>
+          <a:ln>
+            <a:noFill/>
+          </a:ln>
+        </p:spPr>
+        <p:txBody>
+          <a:bodyPr anchorCtr="0" anchor="t" bIns="0" lIns="0" spcFirstLastPara="1" rIns="0" wrap="square" tIns="0">
+            <a:noAutofit/>
+          </a:bodyPr>
+          <a:lstStyle/>
+          <a:p>
+            <a:pPr marL="0" indent="0" lvl="0" marR="0" rtl="0" algn="l">
+              <a:spcBef>
+                <a:spcPts val="0"/>
+              </a:spcBef>
+              <a:spcAft>
+                <a:spcPts val="0"/>
+              </a:spcAft>
+              <a:buNone/>
+            </a:pPr>
+            <a:r>
+              <a:rPr b="1" lang="en-US" sz="2400">
+                <a:solidFill>
+                  <a:srgbClr val="FFB81C"/>
+                </a:solidFill>
+                <a:latin typeface="Calibri"/>
+                <a:ea typeface="Calibri"/>
+                <a:cs typeface="Calibri"/>
+                <a:sym typeface="Calibri"/>
+              </a:rPr>
+              <a:t>02</a:t>
+            </a:r>
+          </a:p>
+        </p:txBody>
+      </p:sp>
+      <p:sp>
+        <p:nvSpPr>
+          <p:cNvPr id="213" name="Text 213"/>
+          <p:cNvSpPr txBox="1"/>
+          <p:nvPr/>
+        </p:nvSpPr>
+        <p:spPr>
+          <a:xfrm>
+            <a:off x="7772400" y="2468880"/>
+            <a:ext cx="3895344" cy="292608"/>
+          </a:xfrm>
+          <a:prstGeom prst="rect">
+            <a:avLst/>
+          </a:prstGeom>
+          <a:noFill/>
+          <a:ln>
+            <a:noFill/>
+          </a:ln>
+        </p:spPr>
+        <p:txBody>
+          <a:bodyPr anchorCtr="0" anchor="t" bIns="0" lIns="0" spcFirstLastPara="1" rIns="0" wrap="square" tIns="0">
+            <a:noAutofit/>
+          </a:bodyPr>
+          <a:lstStyle/>
+          <a:p>
+            <a:pPr marL="0" indent="0" lvl="0" marR="0" rtl="0" algn="l">
+              <a:spcBef>
+                <a:spcPts val="0"/>
+              </a:spcBef>
+              <a:spcAft>
+                <a:spcPts val="0"/>
+              </a:spcAft>
+              <a:buNone/>
+            </a:pPr>
+            <a:r>
+              <a:rPr b="1" lang="en-US" sz="1650">
+                <a:solidFill>
+                  <a:srgbClr val="154734"/>
+                </a:solidFill>
+                <a:latin typeface="Calibri"/>
+                <a:ea typeface="Calibri"/>
+                <a:cs typeface="Calibri"/>
+                <a:sym typeface="Calibri"/>
+              </a:rPr>
+              <a:t>Keep going until it clicks</a:t>
+            </a:r>
+          </a:p>
+        </p:txBody>
+      </p:sp>
+      <p:sp>
+        <p:nvSpPr>
+          <p:cNvPr id="214" name="Text 214"/>
+          <p:cNvSpPr txBox="1"/>
+          <p:nvPr/>
+        </p:nvSpPr>
+        <p:spPr>
+          <a:xfrm>
+            <a:off x="7772400" y="2816352"/>
+            <a:ext cx="3895344" cy="640080"/>
+          </a:xfrm>
+          <a:prstGeom prst="rect">
+            <a:avLst/>
+          </a:prstGeom>
+          <a:noFill/>
+          <a:ln>
+            <a:noFill/>
+          </a:ln>
+        </p:spPr>
+        <p:txBody>
+          <a:bodyPr anchorCtr="0" anchor="t" bIns="0" lIns="0" spcFirstLastPara="1" rIns="0" wrap="square" tIns="0">
+            <a:noAutofit/>
+          </a:bodyPr>
+          <a:lstStyle/>
+          <a:p>
+            <a:pPr marL="0" indent="0" lvl="0" marR="0" rtl="0" algn="l">
+              <a:spcBef>
+                <a:spcPts val="0"/>
+              </a:spcBef>
+              <a:spcAft>
+                <a:spcPts val="0"/>
+              </a:spcAft>
+              <a:buNone/>
+            </a:pPr>
+            <a:r>
+              <a:rPr b="0" lang="en-US" sz="1575">
+                <a:solidFill>
+                  <a:srgbClr val="1A1A1A"/>
+                </a:solidFill>
+                <a:latin typeface="Calibri"/>
+                <a:ea typeface="Calibri"/>
+                <a:cs typeface="Calibri"/>
+                <a:sym typeface="Calibri"/>
+              </a:rPr>
+              <a:t>Ask for simpler words or an example. It remembers the page and what you asked.</a:t>
+            </a:r>
+          </a:p>
+        </p:txBody>
+      </p:sp>
+      <p:sp>
+        <p:nvSpPr>
+          <p:cNvPr id="215" name="Text 215"/>
+          <p:cNvSpPr txBox="1"/>
+          <p:nvPr/>
+        </p:nvSpPr>
+        <p:spPr>
+          <a:xfrm>
+            <a:off x="7178040" y="3511296"/>
+            <a:ext cx="548640" cy="457200"/>
+          </a:xfrm>
+          <a:prstGeom prst="rect">
+            <a:avLst/>
+          </a:prstGeom>
+          <a:noFill/>
+          <a:ln>
+            <a:noFill/>
+          </a:ln>
+        </p:spPr>
+        <p:txBody>
+          <a:bodyPr anchorCtr="0" anchor="t" bIns="0" lIns="0" spcFirstLastPara="1" rIns="0" wrap="square" tIns="0">
+            <a:noAutofit/>
+          </a:bodyPr>
+          <a:lstStyle/>
+          <a:p>
+            <a:pPr marL="0" indent="0" lvl="0" marR="0" rtl="0" algn="l">
+              <a:spcBef>
+                <a:spcPts val="0"/>
+              </a:spcBef>
+              <a:spcAft>
+                <a:spcPts val="0"/>
+              </a:spcAft>
+              <a:buNone/>
+            </a:pPr>
+            <a:r>
+              <a:rPr b="1" lang="en-US" sz="2400">
+                <a:solidFill>
+                  <a:srgbClr val="FFB81C"/>
+                </a:solidFill>
+                <a:latin typeface="Calibri"/>
+                <a:ea typeface="Calibri"/>
+                <a:cs typeface="Calibri"/>
+                <a:sym typeface="Calibri"/>
+              </a:rPr>
+              <a:t>03</a:t>
+            </a:r>
+          </a:p>
+        </p:txBody>
+      </p:sp>
+      <p:sp>
+        <p:nvSpPr>
+          <p:cNvPr id="216" name="Text 216"/>
+          <p:cNvSpPr txBox="1"/>
+          <p:nvPr/>
+        </p:nvSpPr>
+        <p:spPr>
+          <a:xfrm>
+            <a:off x="7772400" y="3566160"/>
+            <a:ext cx="3895344" cy="292608"/>
+          </a:xfrm>
+          <a:prstGeom prst="rect">
+            <a:avLst/>
+          </a:prstGeom>
+          <a:noFill/>
+          <a:ln>
+            <a:noFill/>
+          </a:ln>
+        </p:spPr>
+        <p:txBody>
+          <a:bodyPr anchorCtr="0" anchor="t" bIns="0" lIns="0" spcFirstLastPara="1" rIns="0" wrap="square" tIns="0">
+            <a:noAutofit/>
+          </a:bodyPr>
+          <a:lstStyle/>
+          <a:p>
+            <a:pPr marL="0" indent="0" lvl="0" marR="0" rtl="0" algn="l">
+              <a:spcBef>
+                <a:spcPts val="0"/>
+              </a:spcBef>
+              <a:spcAft>
+                <a:spcPts val="0"/>
+              </a:spcAft>
+              <a:buNone/>
+            </a:pPr>
+            <a:r>
+              <a:rPr b="1" lang="en-US" sz="1650">
+                <a:solidFill>
+                  <a:srgbClr val="154734"/>
+                </a:solidFill>
+                <a:latin typeface="Calibri"/>
+                <a:ea typeface="Calibri"/>
+                <a:cs typeface="Calibri"/>
+                <a:sym typeface="Calibri"/>
+              </a:rPr>
+              <a:t>It checks you got it</a:t>
+            </a:r>
+          </a:p>
+        </p:txBody>
+      </p:sp>
+      <p:sp>
+        <p:nvSpPr>
+          <p:cNvPr id="217" name="Text 217"/>
+          <p:cNvSpPr txBox="1"/>
+          <p:nvPr/>
+        </p:nvSpPr>
+        <p:spPr>
+          <a:xfrm>
+            <a:off x="7772400" y="3913632"/>
+            <a:ext cx="3895344" cy="640080"/>
+          </a:xfrm>
+          <a:prstGeom prst="rect">
+            <a:avLst/>
+          </a:prstGeom>
+          <a:noFill/>
+          <a:ln>
+            <a:noFill/>
+          </a:ln>
+        </p:spPr>
+        <p:txBody>
+          <a:bodyPr anchorCtr="0" anchor="t" bIns="0" lIns="0" spcFirstLastPara="1" rIns="0" wrap="square" tIns="0">
+            <a:noAutofit/>
+          </a:bodyPr>
+          <a:lstStyle/>
+          <a:p>
+            <a:pPr marL="0" indent="0" lvl="0" marR="0" rtl="0" algn="l">
+              <a:spcBef>
+                <a:spcPts val="0"/>
+              </a:spcBef>
+              <a:spcAft>
+                <a:spcPts val="0"/>
+              </a:spcAft>
+              <a:buNone/>
+            </a:pPr>
+            <a:r>
+              <a:rPr b="0" lang="en-US" sz="1575">
+                <a:solidFill>
+                  <a:srgbClr val="1A1A1A"/>
+                </a:solidFill>
+                <a:latin typeface="Calibri"/>
+                <a:ea typeface="Calibri"/>
+                <a:cs typeface="Calibri"/>
+                <a:sym typeface="Calibri"/>
+              </a:rPr>
+              <a:t>It asks you a quick question back, then offers flashcards.</a:t>
+            </a:r>
+          </a:p>
+        </p:txBody>
+      </p:sp>
+      <p:sp>
+        <p:nvSpPr>
+          <p:cNvPr id="218" name="Text 218"/>
+          <p:cNvSpPr txBox="1"/>
+          <p:nvPr/>
+        </p:nvSpPr>
+        <p:spPr>
+          <a:xfrm>
+            <a:off x="7178040" y="4608576"/>
+            <a:ext cx="548640" cy="457200"/>
+          </a:xfrm>
+          <a:prstGeom prst="rect">
+            <a:avLst/>
+          </a:prstGeom>
+          <a:noFill/>
+          <a:ln>
+            <a:noFill/>
+          </a:ln>
+        </p:spPr>
+        <p:txBody>
+          <a:bodyPr anchorCtr="0" anchor="t" bIns="0" lIns="0" spcFirstLastPara="1" rIns="0" wrap="square" tIns="0">
+            <a:noAutofit/>
+          </a:bodyPr>
+          <a:lstStyle/>
+          <a:p>
+            <a:pPr marL="0" indent="0" lvl="0" marR="0" rtl="0" algn="l">
+              <a:spcBef>
+                <a:spcPts val="0"/>
+              </a:spcBef>
+              <a:spcAft>
+                <a:spcPts val="0"/>
+              </a:spcAft>
+              <a:buNone/>
+            </a:pPr>
+            <a:r>
+              <a:rPr b="1" lang="en-US" sz="2400">
+                <a:solidFill>
+                  <a:srgbClr val="FFB81C"/>
+                </a:solidFill>
+                <a:latin typeface="Calibri"/>
+                <a:ea typeface="Calibri"/>
+                <a:cs typeface="Calibri"/>
+                <a:sym typeface="Calibri"/>
+              </a:rPr>
+              <a:t>04</a:t>
+            </a:r>
+          </a:p>
+        </p:txBody>
+      </p:sp>
+      <p:sp>
+        <p:nvSpPr>
+          <p:cNvPr id="219" name="Text 219"/>
+          <p:cNvSpPr txBox="1"/>
+          <p:nvPr/>
+        </p:nvSpPr>
+        <p:spPr>
+          <a:xfrm>
+            <a:off x="7772400" y="4663440"/>
+            <a:ext cx="3895344" cy="292608"/>
+          </a:xfrm>
+          <a:prstGeom prst="rect">
+            <a:avLst/>
+          </a:prstGeom>
+          <a:noFill/>
+          <a:ln>
+            <a:noFill/>
+          </a:ln>
+        </p:spPr>
+        <p:txBody>
+          <a:bodyPr anchorCtr="0" anchor="t" bIns="0" lIns="0" spcFirstLastPara="1" rIns="0" wrap="square" tIns="0">
+            <a:noAutofit/>
+          </a:bodyPr>
+          <a:lstStyle/>
+          <a:p>
+            <a:pPr marL="0" indent="0" lvl="0" marR="0" rtl="0" algn="l">
+              <a:spcBef>
+                <a:spcPts val="0"/>
+              </a:spcBef>
+              <a:spcAft>
+                <a:spcPts val="0"/>
+              </a:spcAft>
+              <a:buNone/>
+            </a:pPr>
+            <a:r>
+              <a:rPr b="1" lang="en-US" sz="1650">
+                <a:solidFill>
+                  <a:srgbClr val="154734"/>
+                </a:solidFill>
+                <a:latin typeface="Calibri"/>
+                <a:ea typeface="Calibri"/>
+                <a:cs typeface="Calibri"/>
+                <a:sym typeface="Calibri"/>
+              </a:rPr>
+              <a:t>Talk to it out loud</a:t>
+            </a:r>
+          </a:p>
+        </p:txBody>
+      </p:sp>
+      <p:sp>
+        <p:nvSpPr>
+          <p:cNvPr id="220" name="Text 220"/>
+          <p:cNvSpPr txBox="1"/>
+          <p:nvPr/>
+        </p:nvSpPr>
+        <p:spPr>
+          <a:xfrm>
+            <a:off x="7772400" y="5010912"/>
+            <a:ext cx="3895344" cy="640080"/>
+          </a:xfrm>
+          <a:prstGeom prst="rect">
+            <a:avLst/>
+          </a:prstGeom>
+          <a:noFill/>
+          <a:ln>
+            <a:noFill/>
+          </a:ln>
+        </p:spPr>
+        <p:txBody>
+          <a:bodyPr anchorCtr="0" anchor="t" bIns="0" lIns="0" spcFirstLastPara="1" rIns="0" wrap="square" tIns="0">
+            <a:noAutofit/>
+          </a:bodyPr>
+          <a:lstStyle/>
+          <a:p>
+            <a:pPr marL="0" indent="0" lvl="0" marR="0" rtl="0" algn="l">
+              <a:spcBef>
+                <a:spcPts val="0"/>
+              </a:spcBef>
+              <a:spcAft>
+                <a:spcPts val="0"/>
+              </a:spcAft>
+              <a:buNone/>
+            </a:pPr>
+            <a:r>
+              <a:rPr b="0" lang="en-US" sz="1575">
+                <a:solidFill>
+                  <a:srgbClr val="1A1A1A"/>
+                </a:solidFill>
+                <a:latin typeface="Calibri"/>
+                <a:ea typeface="Calibri"/>
+                <a:cs typeface="Calibri"/>
+                <a:sym typeface="Calibri"/>
+              </a:rPr>
+              <a:t>Voice input comes in the winter release.</a:t>
+            </a:r>
+          </a:p>
+        </p:txBody>
+      </p:sp>
+    </p:spTree>
+  </p:cSld>
+  <p:clrMapOvr>
+    <a:masterClrMapping/>
+  </p:clrMapOvr>
+</p:sld>
+</file>
+
+<file path=ppt/slides/slide6.xml><?xml version="1.0" encoding="utf-8"?>
+<p:sld xmlns:a="http://schemas.openxmlformats.org/drawingml/2006/main" xmlns:p="http://schemas.openxmlformats.org/presentationml/2006/main" xmlns:r="http://schemas.openxmlformats.org/officeDocument/2006/relationships">
+  <p:cSld>
+    <p:bg>
+      <p:bgPr>
+        <a:solidFill>
+          <a:srgbClr val="FFFFFF"/>
+        </a:solidFill>
+        <a:effectLst/>
+      </p:bgPr>
+    </p:bg>
+    <p:spTree>
+      <p:nvGrpSpPr>
+        <p:cNvPr id="1" name=""/>
+        <p:cNvGrpSpPr/>
+        <p:nvPr/>
+      </p:nvGrpSpPr>
+      <p:grpSpPr/>
+      <p:sp>
+        <p:nvSpPr>
+          <p:cNvPr id="214" name="Google Shape;214;p10"/>
+          <p:cNvSpPr/>
+          <p:nvPr/>
+        </p:nvSpPr>
+        <p:spPr>
+          <a:xfrm>
+            <a:off x="514350" y="428625"/>
+            <a:ext cx="8477250" cy="628650"/>
+          </a:xfrm>
+          <a:prstGeom prst="rect">
+            <a:avLst/>
+          </a:prstGeom>
+          <a:noFill/>
+          <a:ln>
+            <a:noFill/>
+          </a:ln>
+        </p:spPr>
+        <p:txBody>
+          <a:bodyPr anchorCtr="0" anchor="t" bIns="0" lIns="0" spcFirstLastPara="1" rIns="0" wrap="square" tIns="0">
+            <a:noAutofit/>
+          </a:bodyPr>
+          <a:lstStyle/>
+          <a:p>
+            <a:pPr indent="0" lvl="0" marL="0" marR="0" rtl="0" algn="l">
+              <a:spcBef>
+                <a:spcPts val="0"/>
+              </a:spcBef>
+              <a:spcAft>
+                <a:spcPts val="0"/>
+              </a:spcAft>
+              <a:buNone/>
+            </a:pPr>
+            <a:r>
+              <a:rPr b="1" lang="en-US" sz="3000">
+                <a:solidFill>
+                  <a:srgbClr val="154734"/>
+                </a:solidFill>
+                <a:latin typeface="Calibri"/>
+                <a:ea typeface="Calibri"/>
+                <a:cs typeface="Calibri"/>
+                <a:sym typeface="Calibri"/>
+              </a:rPr>
+              <a:t>What makes it different</a:t>
+            </a:r>
+          </a:p>
+        </p:txBody>
+      </p:sp>
+      <p:sp>
+        <p:nvSpPr>
+          <p:cNvPr id="215" name="Google Shape;215;p10"/>
+          <p:cNvSpPr/>
+          <p:nvPr/>
+        </p:nvSpPr>
+        <p:spPr>
+          <a:xfrm>
+            <a:off x="9286875" y="409575"/>
+            <a:ext cx="2381250" cy="361950"/>
+          </a:xfrm>
+          <a:prstGeom prst="roundRect">
+            <a:avLst>
+              <a:gd fmla="val 39474" name="adj"/>
+            </a:avLst>
+          </a:prstGeom>
+          <a:solidFill>
+            <a:srgbClr val="FFB81C"/>
+          </a:solidFill>
+          <a:ln>
+            <a:noFill/>
+          </a:ln>
+        </p:spPr>
+        <p:txBody>
+          <a:bodyPr anchorCtr="0" anchor="ctr" bIns="91425" lIns="91425" spcFirstLastPara="1" rIns="91425" wrap="square" tIns="91425">
+            <a:noAutofit/>
+          </a:bodyPr>
+          <a:lstStyle/>
+          <a:p>
+            <a:pPr indent="0" lvl="0" marL="0" rtl="0" algn="l">
+              <a:spcBef>
+                <a:spcPts val="0"/>
+              </a:spcBef>
+              <a:spcAft>
+                <a:spcPts val="0"/>
+              </a:spcAft>
+              <a:buNone/>
+            </a:pPr>
+            <a:r>
+              <a:t/>
+            </a:r>
+            <a:endParaRPr/>
+          </a:p>
+        </p:txBody>
+      </p:sp>
+      <p:sp>
+        <p:nvSpPr>
+          <p:cNvPr id="216" name="Google Shape;216;p10"/>
+          <p:cNvSpPr/>
+          <p:nvPr/>
+        </p:nvSpPr>
+        <p:spPr>
+          <a:xfrm>
+            <a:off x="9382125" y="485775"/>
+            <a:ext cx="2190750" cy="219075"/>
+          </a:xfrm>
+          <a:prstGeom prst="rect">
+            <a:avLst/>
+          </a:prstGeom>
+          <a:noFill/>
+          <a:ln>
+            <a:noFill/>
+          </a:ln>
+        </p:spPr>
+        <p:txBody>
+          <a:bodyPr anchorCtr="0" anchor="t" bIns="0" lIns="0" spcFirstLastPara="1" rIns="0" wrap="square" tIns="0">
+            <a:noAutofit/>
+          </a:bodyPr>
+          <a:lstStyle/>
+          <a:p>
+            <a:pPr indent="0" lvl="0" marL="0" marR="0" rtl="0" algn="ctr">
+              <a:spcBef>
+                <a:spcPts val="0"/>
+              </a:spcBef>
+              <a:spcAft>
+                <a:spcPts val="0"/>
+              </a:spcAft>
+              <a:buNone/>
+            </a:pPr>
+            <a:r>
+              <a:rPr b="1" lang="en-US" sz="1200">
+                <a:solidFill>
+                  <a:srgbClr val="154734"/>
+                </a:solidFill>
+                <a:latin typeface="Calibri"/>
+                <a:ea typeface="Calibri"/>
+                <a:cs typeface="Calibri"/>
+                <a:sym typeface="Calibri"/>
+              </a:rPr>
+              <a:t>VALUE + STRATEGY</a:t>
+            </a:r>
+          </a:p>
+        </p:txBody>
+      </p:sp>
+      <p:cxnSp>
+        <p:nvCxnSpPr>
+          <p:cNvPr id="217" name="Google Shape;217;p10"/>
+          <p:cNvCxnSpPr/>
+          <p:nvPr/>
+        </p:nvCxnSpPr>
+        <p:spPr>
+          <a:xfrm>
+            <a:off x="0" y="6819900"/>
+            <a:ext cx="12191695" cy="0"/>
+          </a:xfrm>
+          <a:prstGeom prst="straightConnector1">
+            <a:avLst/>
+          </a:prstGeom>
+          <a:noFill/>
+          <a:ln cap="flat" cmpd="sng" w="47625">
+            <a:solidFill>
+              <a:srgbClr val="FFB81C"/>
+            </a:solidFill>
+            <a:prstDash val="solid"/>
+            <a:round/>
+            <a:headEnd len="sm" w="sm" type="none"/>
+            <a:tailEnd len="sm" w="sm" type="none"/>
+          </a:ln>
+        </p:spPr>
+      </p:cxnSp>
+      <p:sp>
+        <p:nvSpPr>
           <p:cNvPr id="218" name="Google Shape;218;p10"/>
           <p:cNvSpPr/>
           <p:nvPr/>
@@ -5202,7 +7468,7 @@
                 <a:cs typeface="Calibri"/>
                 <a:sym typeface="Calibri"/>
               </a:rPr>
-              <a:t>4</a:t>
+              <a:t>6</a:t>
             </a:r>
           </a:p>
         </p:txBody>
@@ -6043,7 +8309,7 @@
 </p:sld>
 </file>
 
-<file path=ppt/slides/slide5.xml><?xml version="1.0" encoding="utf-8"?>
+<file path=ppt/slides/slide7.xml><?xml version="1.0" encoding="utf-8"?>
 <p:sld xmlns:a="http://schemas.openxmlformats.org/drawingml/2006/main" xmlns:p="http://schemas.openxmlformats.org/presentationml/2006/main" xmlns:r="http://schemas.openxmlformats.org/officeDocument/2006/relationships">
   <p:cSld>
     <p:bg>
@@ -6274,7 +8540,7 @@
                 <a:cs typeface="Calibri"/>
                 <a:sym typeface="Calibri"/>
               </a:rPr>
-              <a:t>5</a:t>
+              <a:t>7</a:t>
             </a:r>
           </a:p>
         </p:txBody>
@@ -7391,7 +9657,7 @@
 </p:sld>
 </file>
 
-<file path=ppt/slides/slide6.xml><?xml version="1.0" encoding="utf-8"?>
+<file path=ppt/slides/slide8.xml><?xml version="1.0" encoding="utf-8"?>
 <p:sld xmlns:a="http://schemas.openxmlformats.org/drawingml/2006/main" xmlns:p="http://schemas.openxmlformats.org/presentationml/2006/main" xmlns:r="http://schemas.openxmlformats.org/officeDocument/2006/relationships">
   <p:cSld>
     <p:bg>
@@ -7622,7 +9888,7 @@
                 <a:cs typeface="Calibri"/>
                 <a:sym typeface="Calibri"/>
               </a:rPr>
-              <a:t>6</a:t>
+              <a:t>8</a:t>
             </a:r>
           </a:p>
         </p:txBody>
@@ -8713,7 +10979,7 @@
 </p:sld>
 </file>
 
-<file path=ppt/slides/slide7.xml><?xml version="1.0" encoding="utf-8"?>
+<file path=ppt/slides/slide9.xml><?xml version="1.0" encoding="utf-8"?>
 <p:sld xmlns:a="http://schemas.openxmlformats.org/drawingml/2006/main" xmlns:p="http://schemas.openxmlformats.org/presentationml/2006/main" xmlns:r="http://schemas.openxmlformats.org/officeDocument/2006/relationships">
   <p:cSld>
     <p:bg>

</xml_diff>